<commit_message>
HW7 slides: live GUI screenshot on slide 6, timed 4-minute script
- Slide 6 now shows new-gui mid-run: Fuchsia hovering over Ethan's cap
  after the AI's inspect_closer was approved, cap visible in the camera pane
- Speaker notes rewritten as a timed script (~3:50, 533 words)
- gui_autostart.py --shots: save window grabs; run_demo.sh uses it every 30 s
- evidence/e2e/full-run-3-gui: the run the screenshot comes from

Co-Authored-By: Claude Opus 5.5 <noreply@anthropic.com>
</commit_message>
<xml_diff>
--- a/hw07/slides/HW7-clue-pipeline.pptx
+++ b/hw07/slides/HW7-clue-pipeline.pptx
@@ -4,6 +4,9 @@
   <p:sldMasterIdLst>
     <p:sldMasterId id="2147483648" r:id="rId1"/>
   </p:sldMasterIdLst>
+  <p:notesMasterIdLst>
+    <p:notesMasterId r:id="rId8"/>
+  </p:notesMasterIdLst>
   <p:sldIdLst>
     <p:sldId id="256" r:id="rId2"/>
     <p:sldId id="257" r:id="rId3"/>
@@ -12,10 +15,7 @@
     <p:sldId id="260" r:id="rId6"/>
     <p:sldId id="261" r:id="rId7"/>
   </p:sldIdLst>
-  <p:notesMasterIdLst>
-    <p:notesMasterId r:id="rId8"/>
-  </p:notesMasterIdLst>
-  <p:sldSz cx="9144000" cy="5143500"/>
+  <p:sldSz cx="9144000" cy="5143500" type="screen16x9"/>
   <p:notesSz cx="5143500" cy="9144000"/>
   <p:defaultTextStyle>
     <a:lvl1pPr marL="0" algn="l" defTabSz="914400" rtl="0" eaLnBrk="1" latinLnBrk="0" hangingPunct="1">
@@ -109,6 +109,11 @@
       </a:defRPr>
     </a:lvl9pPr>
   </p:defaultTextStyle>
+  <p:extLst>
+    <p:ext uri="{EFAFB233-063F-42B5-8137-9DF3F51BA10A}">
+      <p15:sldGuideLst xmlns:p15="http://schemas.microsoft.com/office/powerpoint/2012/main"/>
+    </p:ext>
+  </p:extLst>
 </p:presentation>
 </file>
 
@@ -134,234 +139,10 @@
           <a:chExt cx="0" cy="0"/>
         </a:xfrm>
       </p:grpSpPr>
-      <p:sp>
-        <p:nvSpPr>
-          <p:cNvPr id="2" name="Header Placeholder 1"/>
-          <p:cNvSpPr>
-            <a:spLocks noGrp="1"/>
-          </p:cNvSpPr>
-          <p:nvPr>
-            <p:ph type="hdr" sz="quarter"/>
-          </p:nvPr>
-        </p:nvSpPr>
-        <p:spPr>
-          <a:xfrm>
-            <a:off x="0" y="0"/>
-            <a:ext cx="2971800" cy="458788"/>
-          </a:xfrm>
-          <a:prstGeom prst="rect">
-            <a:avLst/>
-          </a:prstGeom>
-        </p:spPr>
-        <p:txBody>
-          <a:bodyPr vert="horz" lIns="91440" tIns="45720" rIns="91440" bIns="45720" rtlCol="0"/>
-          <a:lstStyle>
-            <a:lvl1pPr algn="l">
-              <a:defRPr sz="1200"/>
-            </a:lvl1pPr>
-          </a:lstStyle>
-          <a:p>
-            <a:endParaRPr lang="en-US"/>
-          </a:p>
-        </p:txBody>
-      </p:sp>
-      <p:sp>
-        <p:nvSpPr>
-          <p:cNvPr id="3" name="Date Placeholder 2"/>
-          <p:cNvSpPr>
-            <a:spLocks noGrp="1"/>
-          </p:cNvSpPr>
-          <p:nvPr>
-            <p:ph type="dt" idx="1"/>
-          </p:nvPr>
-        </p:nvSpPr>
-        <p:spPr>
-          <a:xfrm>
-            <a:off x="3884613" y="0"/>
-            <a:ext cx="2971800" cy="458788"/>
-          </a:xfrm>
-          <a:prstGeom prst="rect">
-            <a:avLst/>
-          </a:prstGeom>
-        </p:spPr>
-        <p:txBody>
-          <a:bodyPr vert="horz" lIns="91440" tIns="45720" rIns="91440" bIns="45720" rtlCol="0"/>
-          <a:lstStyle>
-            <a:lvl1pPr algn="r">
-              <a:defRPr sz="1200"/>
-            </a:lvl1pPr>
-          </a:lstStyle>
-          <a:p>
-            <a:fld id="{5282F153-3F37-0F45-9E97-73ACFA13230C}" type="datetimeFigureOut">
-              <a:rPr lang="en-US"/>
-              <a:t>7/23/19</a:t>
-            </a:fld>
-            <a:endParaRPr lang="en-US"/>
-          </a:p>
-        </p:txBody>
-      </p:sp>
-      <p:sp>
-        <p:nvSpPr>
-          <p:cNvPr id="4" name="Slide Image Placeholder 3"/>
-          <p:cNvSpPr>
-            <a:spLocks noGrp="1" noRot="1" noChangeAspect="1"/>
-          </p:cNvSpPr>
-          <p:nvPr>
-            <p:ph type="sldImg" idx="2"/>
-          </p:nvPr>
-        </p:nvSpPr>
-        <p:spPr>
-          <a:xfrm>
-            <a:off x="685800" y="1143000"/>
-            <a:ext cx="5486400" cy="3086100"/>
-          </a:xfrm>
-          <a:prstGeom prst="rect">
-            <a:avLst/>
-          </a:prstGeom>
-          <a:noFill/>
-          <a:ln w="12700">
-            <a:solidFill>
-              <a:prstClr val="black"/>
-            </a:solidFill>
-          </a:ln>
-        </p:spPr>
-        <p:txBody>
-          <a:bodyPr vert="horz" lIns="91440" tIns="45720" rIns="91440" bIns="45720" rtlCol="0" anchor="ctr"/>
-          <a:lstStyle/>
-          <a:p>
-            <a:endParaRPr lang="en-US"/>
-          </a:p>
-        </p:txBody>
-      </p:sp>
-      <p:sp>
-        <p:nvSpPr>
-          <p:cNvPr id="5" name="Notes Placeholder 4"/>
-          <p:cNvSpPr>
-            <a:spLocks noGrp="1"/>
-          </p:cNvSpPr>
-          <p:nvPr>
-            <p:ph type="body" sz="quarter" idx="3"/>
-          </p:nvPr>
-        </p:nvSpPr>
-        <p:spPr>
-          <a:xfrm>
-            <a:off x="685800" y="4400550"/>
-            <a:ext cx="5486400" cy="3600450"/>
-          </a:xfrm>
-          <a:prstGeom prst="rect">
-            <a:avLst/>
-          </a:prstGeom>
-        </p:spPr>
-        <p:txBody>
-          <a:bodyPr vert="horz" lIns="91440" tIns="45720" rIns="91440" bIns="45720" rtlCol="0"/>
-          <a:lstStyle/>
-          <a:p>
-            <a:pPr lvl="0"/>
-            <a:r>
-              <a:rPr lang="en-US"/>
-              <a:t>Click to edit Master text styles</a:t>
-            </a:r>
-          </a:p>
-          <a:p>
-            <a:pPr lvl="1"/>
-            <a:r>
-              <a:rPr lang="en-US"/>
-              <a:t>Second level</a:t>
-            </a:r>
-          </a:p>
-          <a:p>
-            <a:pPr lvl="2"/>
-            <a:r>
-              <a:rPr lang="en-US"/>
-              <a:t>Third level</a:t>
-            </a:r>
-          </a:p>
-          <a:p>
-            <a:pPr lvl="3"/>
-            <a:r>
-              <a:rPr lang="en-US"/>
-              <a:t>Fourth level</a:t>
-            </a:r>
-          </a:p>
-          <a:p>
-            <a:pPr lvl="4"/>
-            <a:r>
-              <a:rPr lang="en-US"/>
-              <a:t>Fifth level</a:t>
-            </a:r>
-          </a:p>
-        </p:txBody>
-      </p:sp>
-      <p:sp>
-        <p:nvSpPr>
-          <p:cNvPr id="6" name="Footer Placeholder 5"/>
-          <p:cNvSpPr>
-            <a:spLocks noGrp="1"/>
-          </p:cNvSpPr>
-          <p:nvPr>
-            <p:ph type="ftr" sz="quarter" idx="4"/>
-          </p:nvPr>
-        </p:nvSpPr>
-        <p:spPr>
-          <a:xfrm>
-            <a:off x="0" y="8685213"/>
-            <a:ext cx="2971800" cy="458787"/>
-          </a:xfrm>
-          <a:prstGeom prst="rect">
-            <a:avLst/>
-          </a:prstGeom>
-        </p:spPr>
-        <p:txBody>
-          <a:bodyPr vert="horz" lIns="91440" tIns="45720" rIns="91440" bIns="45720" rtlCol="0" anchor="b"/>
-          <a:lstStyle>
-            <a:lvl1pPr algn="l">
-              <a:defRPr sz="1200"/>
-            </a:lvl1pPr>
-          </a:lstStyle>
-          <a:p>
-            <a:endParaRPr lang="en-US"/>
-          </a:p>
-        </p:txBody>
-      </p:sp>
-      <p:sp>
-        <p:nvSpPr>
-          <p:cNvPr id="7" name="Slide Number Placeholder 6"/>
-          <p:cNvSpPr>
-            <a:spLocks noGrp="1"/>
-          </p:cNvSpPr>
-          <p:nvPr>
-            <p:ph type="sldNum" sz="quarter" idx="5"/>
-          </p:nvPr>
-        </p:nvSpPr>
-        <p:spPr>
-          <a:xfrm>
-            <a:off x="3884613" y="8685213"/>
-            <a:ext cx="2971800" cy="458787"/>
-          </a:xfrm>
-          <a:prstGeom prst="rect">
-            <a:avLst/>
-          </a:prstGeom>
-        </p:spPr>
-        <p:txBody>
-          <a:bodyPr vert="horz" lIns="91440" tIns="45720" rIns="91440" bIns="45720" rtlCol="0" anchor="b"/>
-          <a:lstStyle>
-            <a:lvl1pPr algn="r">
-              <a:defRPr sz="1200"/>
-            </a:lvl1pPr>
-          </a:lstStyle>
-          <a:p>
-            <a:fld id="{CE5E9CC1-C706-0F49-92D6-E571CC5EEA8F}" type="slidenum">
-              <a:rPr lang="en-US"/>
-              <a:t>‹#›</a:t>
-            </a:fld>
-            <a:endParaRPr lang="en-US"/>
-          </a:p>
-        </p:txBody>
-      </p:sp>
     </p:spTree>
     <p:extLst>
       <p:ext uri="{BB962C8B-B14F-4D97-AF65-F5344CB8AC3E}">
-        <p14:creationId xmlns:p14="http://schemas.microsoft.com/office/powerpoint/2010/main" val="1024086991"/>
+        <p14:creationId xmlns:p14="http://schemas.microsoft.com/office/powerpoint/2010/main" val="3179514712"/>
       </p:ext>
     </p:extLst>
   </p:cSld>
@@ -506,8 +287,8 @@
           <a:lstStyle/>
           <a:p>
             <a:r>
-              <a:rPr lang="en-US" dirty="0"/>
-              <a:t>Hi, I'm Yitong. HW7: a search drone finds things before it finds people. My pipeline decides what each object means for this search, and my HW6 planner decides whether anything flies. The model proposes; code decides.</a:t>
+              <a:rPr lang="en-US" smtClean="0"/>
+              <a:t>[0:00-0:20] Hi, I'm Yitong. A search drone finds things before it finds people: a cap, a backpack, a doll. My HW7 pipeline decides what each object means for this search, and my HW6 planner decides whether anything actually flies. In one line: the model proposes, code decides.</a:t>
             </a:r>
             <a:endParaRPr lang="en-US" dirty="0"/>
           </a:p>
@@ -594,8 +375,8 @@
           <a:lstStyle/>
           <a:p>
             <a:r>
-              <a:rPr lang="en-US" dirty="0"/>
-              <a:t>Stage 1 is given. Describe sees only pixels, so it can't see what it's hoping for. Relevance and Decide get text only, which makes every mistake traceable to one stage. Decide picks from a menu; the model never writes a coordinate. My code sets the centre, allows one closer look, and then the same HW6 validator that checks the operator checks the AI.</a:t>
+              <a:rPr lang="en-US" smtClean="0"/>
+              <a:t>[0:20-1:05] Stage 1, detection, is given. Then three Claude stages, each with its own schema. Describe sees only the pixels, never who is missing, so it can't see what it is hoping to find. Relevance compares that description with the person, text only. Decide picks one action from a fixed menu: ignore, log only, inspect closer, or converge. Because Relevance and Decide only see text, every mistake can be traced to one stage. The model never writes a coordinate: my code sets the search centre to the candidate's position and allows at most one closer look. Then the same HW6 validator that checks the operator checks the AI.</a:t>
             </a:r>
             <a:endParaRPr lang="en-US" dirty="0"/>
           </a:p>
@@ -682,8 +463,8 @@
           <a:lstStyle/>
           <a:p>
             <a:r>
-              <a:rPr lang="en-US" dirty="0"/>
-              <a:t>People image boy-greenshirt. Two of his things, four decoys. The near miss is a navy beanie: same colour as his cap, wrong kind of hat. All six lie under UAV 1's HW6 search route; check_set.py reports OK.</a:t>
+              <a:rPr lang="en-US" smtClean="0"/>
+              <a:t>[1:05-1:35] My test set is Ethan, eight, near the north gate. I wrote his description first: navy cap with a grey front, green tee, orange backpack with a dinosaur patch. Two of his things, four decoys. The near miss is a navy beanie: right colour, wrong kind of hat. The shoe is adult size, the doll is a child's toy but not his, and the ball is tempting at a stadium. check_set.py reports OK.</a:t>
             </a:r>
             <a:endParaRPr lang="en-US" dirty="0"/>
           </a:p>
@@ -770,8 +551,8 @@
           <a:lstStyle/>
           <a:p>
             <a:r>
-              <a:rPr lang="en-US" dirty="0"/>
-              <a:t>Default model, final prompts: 100 percent on both sets, 93 percent agreement on three repeats. About two cents per clue. But evaluate.py renders are much sharper than what the GUI camera gives in flight.</a:t>
+              <a:rPr lang="en-US" smtClean="0"/>
+              <a:t>[1:35-2:10] Offline, with evaluate.py: fifteen out of fifteen on Lily's set over three repeats, six out of six on mine, and 93 percent agreement across repeats. The one disagreement was Lily's shoe, log only twice and ignore once, both acceptable. About two cents and three Claude calls per clue. But these renders are sharp, and the GUI camera in flight is not. That is where it broke.</a:t>
             </a:r>
             <a:endParaRPr lang="en-US" dirty="0"/>
           </a:p>
@@ -858,8 +639,8 @@
           <a:lstStyle/>
           <a:p>
             <a:r>
-              <a:rPr lang="en-US" dirty="0"/>
-              <a:t>Replaying the real flight crops: the cap came out log_only. Describe was honest about the blur. Relevance was the first wrong stage: one candidate_item field made it commit to the shorts first. Fix: list every possible item before choosing, and a rule for unclear descriptions. First version over-fired on the soccer ball, so I added the outline. Offline stayed 100 percent.</a:t>
+              <a:rPr lang="en-US" smtClean="0"/>
+              <a:t>[2:10-3:00] In flight, Ethan's cap is this blur on the left. The cap came out log only, so his cap was filed away. I traced it stage by stage. Describe was honest: a blurry blue object with a grey oval, low confidence, needs a closer look. Relevance was the first wrong stage: its schema made it fill in one candidate item first, it committed to the denim shorts, and said low, while its own rationale mentioned the cap. The fix: list every possible item before choosing, and a rule that an unclear object whose colour, size and outline fit is medium. Now it goes inspect closer, the drone hovers, and the zoomed look comes back high, then converge. I re-ran both test sets afterwards: still 100 percent offline.</a:t>
             </a:r>
             <a:endParaRPr lang="en-US" dirty="0"/>
           </a:p>
@@ -946,8 +727,8 @@
           <a:lstStyle/>
           <a:p>
             <a:r>
-              <a:rPr lang="en-US" dirty="0"/>
-              <a:t>Full run in new-gui: his cap and backpack got a hover, the decoys flew nothing, and the detector's repeats were refused by my validator. Earlier, two AI converges were refused on battery reserve: the same rule that refuses an operator. The model proposes; code decides. Thank you.</a:t>
+              <a:rPr lang="en-US" smtClean="0"/>
+              <a:t>[3:00-3:50] Here is the whole system live in new-gui, recorded this morning with one command, run_demo.sh. The detector reported the cap, my pipeline proposed inspect closer, my validator approved it, and Fuchsia is hovering over the cap; you can see it in the camera pane. When the cap was reported again, the validator refused: the UAV was busy and that spot was already covered. Across my full runs, the backpack also got a hover, the decoys flew nothing, and two converges at 26 percent battery were refused on the reserve, the same rule that refuses an operator. Coordinates, feasibility, a second look: never left to the model. Thank you.</a:t>
             </a:r>
             <a:endParaRPr lang="en-US" dirty="0"/>
           </a:p>
@@ -1027,6 +808,7 @@
         <a:solidFill>
           <a:srgbClr val="1B2430"/>
         </a:solidFill>
+        <a:effectLst/>
       </p:bgPr>
     </p:bg>
     <p:spTree>
@@ -1064,7 +846,7 @@
           <a:bodyPr wrap="square" rtlCol="0" anchor="ctr"/>
           <a:lstStyle/>
           <a:p>
-            <a:pPr indent="0" marL="0">
+            <a:pPr marL="0" indent="0">
               <a:buNone/>
             </a:pPr>
             <a:r>
@@ -1102,7 +884,7 @@
           </a:prstGeom>
           <a:extLst>
             <a:ext uri="{C572A759-6A51-4108-AA02-DFA0A04FC94B}">
-              <ma14:wrappingTextBoxFlag xmlns:ma14="http://schemas.microsoft.com/office/mac/drawingml/2011/main" val="0"/>
+              <ma14:wrappingTextBoxFlag xmlns:ma14="http://schemas.microsoft.com/office/mac/drawingml/2011/main" xmlns="" val="0"/>
             </a:ext>
           </a:extLst>
         </p:spPr>
@@ -1123,8 +905,8 @@
           <a:p>
             <a:pPr algn="l"/>
             <a:fld id="{F7021451-1387-4CA6-816F-3879F97B5CBC}" type="slidenum">
-              <a:rPr b="0" lang="en-US"/>
-              <a:t>1002</a:t>
+              <a:rPr lang="en-US" b="0"/>
+              <a:t>‹#›</a:t>
             </a:fld>
             <a:endParaRPr lang="en-US"/>
           </a:p>
@@ -1146,6 +928,7 @@
         <a:solidFill>
           <a:srgbClr val="FFFFFF"/>
         </a:solidFill>
+        <a:effectLst/>
       </p:bgPr>
     </p:bg>
     <p:spTree>
@@ -1183,7 +966,7 @@
           <a:bodyPr wrap="square" rtlCol="0" anchor="ctr"/>
           <a:lstStyle/>
           <a:p>
-            <a:pPr indent="0" marL="0">
+            <a:pPr marL="0" indent="0">
               <a:buNone/>
             </a:pPr>
             <a:r>
@@ -1221,7 +1004,7 @@
           </a:prstGeom>
           <a:extLst>
             <a:ext uri="{C572A759-6A51-4108-AA02-DFA0A04FC94B}">
-              <ma14:wrappingTextBoxFlag xmlns:ma14="http://schemas.microsoft.com/office/mac/drawingml/2011/main" val="0"/>
+              <ma14:wrappingTextBoxFlag xmlns:ma14="http://schemas.microsoft.com/office/mac/drawingml/2011/main" xmlns="" val="0"/>
             </a:ext>
           </a:extLst>
         </p:spPr>
@@ -1242,8 +1025,8 @@
           <a:p>
             <a:pPr algn="l"/>
             <a:fld id="{F7021451-1387-4CA6-816F-3879F97B5CBC}" type="slidenum">
-              <a:rPr b="0" lang="en-US"/>
-              <a:t>1003</a:t>
+              <a:rPr lang="en-US" b="0"/>
+              <a:t>‹#›</a:t>
             </a:fld>
             <a:endParaRPr lang="en-US"/>
           </a:p>
@@ -1260,6 +1043,11 @@
 <file path=ppt/slideMasters/slideMaster1.xml><?xml version="1.0" encoding="utf-8"?>
 <p:sldMaster xmlns:a="http://schemas.openxmlformats.org/drawingml/2006/main" xmlns:r="http://schemas.openxmlformats.org/officeDocument/2006/relationships" xmlns:p="http://schemas.openxmlformats.org/presentationml/2006/main">
   <p:cSld>
+    <p:bg>
+      <p:bgRef idx="1001">
+        <a:schemeClr val="bg1"/>
+      </p:bgRef>
+    </p:bg>
     <p:spTree>
       <p:nvGrpSpPr>
         <p:cNvPr id="1" name=""/>
@@ -1294,7 +1082,7 @@
           </a:prstGeom>
           <a:extLst>
             <a:ext uri="{C572A759-6A51-4108-AA02-DFA0A04FC94B}">
-              <ma14:wrappingTextBoxFlag xmlns:ma14="http://schemas.microsoft.com/office/mac/drawingml/2011/main" val="0"/>
+              <ma14:wrappingTextBoxFlag xmlns:ma14="http://schemas.microsoft.com/office/mac/drawingml/2011/main" xmlns="" val="0"/>
             </a:ext>
           </a:extLst>
         </p:spPr>
@@ -1315,8 +1103,8 @@
           <a:p>
             <a:pPr algn="l"/>
             <a:fld id="{F7021451-1387-4CA6-816F-3879F97B5CBC}" type="slidenum">
-              <a:rPr b="0" lang="en-US"/>
-              <a:t>null</a:t>
+              <a:rPr lang="en-US" b="0"/>
+              <a:t>‹#›</a:t>
             </a:fld>
             <a:endParaRPr lang="en-US"/>
           </a:p>
@@ -1622,7 +1410,7 @@
           <a:bodyPr wrap="square" lIns="0" tIns="0" rIns="0" bIns="0" rtlCol="0" anchor="t"/>
           <a:lstStyle/>
           <a:p>
-            <a:pPr indent="0" marL="0">
+            <a:pPr marL="0" indent="0">
               <a:buNone/>
             </a:pPr>
             <a:r>
@@ -1661,7 +1449,7 @@
           <a:bodyPr wrap="square" lIns="0" tIns="0" rIns="0" bIns="0" rtlCol="0" anchor="t"/>
           <a:lstStyle/>
           <a:p>
-            <a:pPr indent="0" marL="0">
+            <a:pPr marL="0" indent="0">
               <a:buNone/>
             </a:pPr>
             <a:r>
@@ -1678,7 +1466,7 @@
             <a:endParaRPr lang="en-US" sz="4000" dirty="0"/>
           </a:p>
           <a:p>
-            <a:pPr indent="0" marL="0">
+            <a:pPr marL="0" indent="0">
               <a:buNone/>
             </a:pPr>
             <a:r>
@@ -1717,7 +1505,7 @@
           <a:bodyPr wrap="square" lIns="0" tIns="0" rIns="0" bIns="0" rtlCol="0" anchor="t"/>
           <a:lstStyle/>
           <a:p>
-            <a:pPr indent="0" marL="0">
+            <a:pPr marL="0" indent="0">
               <a:buNone/>
             </a:pPr>
             <a:r>
@@ -1762,15 +1550,15 @@
       </p:sp>
       <p:pic>
         <p:nvPicPr>
-          <p:cNvPr id="6" name="Image 0" descr="C:\Users\Yitong\AppData\Local\Temp\claude\--wsl-localhost-Ubuntu-home-yitong-uav-native-ai\5626ac00-b96f-4523-b66d-3cae6d4f4d7e\scratchpad\deck\ethan.png">    </p:cNvPr>
+          <p:cNvPr id="6" name="Image 0" descr="C:\Users\Yitong\AppData\Local\Temp\claude\--wsl-localhost-Ubuntu-home-yitong-uav-native-ai\5626ac00-b96f-4523-b66d-3cae6d4f4d7e\scratchpad\deck\ethan.png"/>
           <p:cNvPicPr>
             <a:picLocks noChangeAspect="1"/>
           </p:cNvPicPr>
           <p:nvPr/>
         </p:nvPicPr>
         <p:blipFill>
-          <a:blip r:embed="rId1"/>
-          <a:srcRect l="0" r="0" t="0" b="0"/>
+          <a:blip r:embed="rId3"/>
+          <a:srcRect/>
           <a:stretch/>
         </p:blipFill>
         <p:spPr>
@@ -1804,7 +1592,7 @@
           <a:bodyPr wrap="square" lIns="0" tIns="0" rIns="0" bIns="0" rtlCol="0" anchor="t"/>
           <a:lstStyle/>
           <a:p>
-            <a:pPr algn="ctr" indent="0" marL="0">
+            <a:pPr marL="0" indent="0" algn="ctr">
               <a:buNone/>
             </a:pPr>
             <a:r>
@@ -1842,7 +1630,7 @@
           </a:prstGeom>
           <a:extLst>
             <a:ext uri="{C572A759-6A51-4108-AA02-DFA0A04FC94B}">
-              <ma14:wrappingTextBoxFlag xmlns:ma14="http://schemas.microsoft.com/office/mac/drawingml/2011/main" val="0"/>
+              <ma14:wrappingTextBoxFlag xmlns:ma14="http://schemas.microsoft.com/office/mac/drawingml/2011/main" xmlns="" val="0"/>
             </a:ext>
           </a:extLst>
         </p:spPr>
@@ -1863,7 +1651,7 @@
           <a:p>
             <a:pPr algn="l"/>
             <a:fld id="{F7021451-1387-4CA6-816F-3879F97B5CBC}" type="slidenum">
-              <a:rPr b="0" lang="en-US"/>
+              <a:rPr lang="en-US" b="0"/>
               <a:t>1</a:t>
             </a:fld>
             <a:endParaRPr lang="en-US"/>
@@ -1916,7 +1704,7 @@
           <a:bodyPr wrap="square" lIns="0" tIns="0" rIns="0" bIns="0" rtlCol="0" anchor="ctr"/>
           <a:lstStyle/>
           <a:p>
-            <a:pPr indent="0" marL="0">
+            <a:pPr marL="0" indent="0">
               <a:buNone/>
             </a:pPr>
             <a:r>
@@ -1960,7 +1748,7 @@
             <a:prstDash val="solid"/>
           </a:ln>
           <a:effectLst>
-            <a:outerShdw sx="100000" sy="100000" kx="0" ky="0" algn="bl" rotWithShape="0" blurRad="50800" dist="19050" dir="5400000">
+            <a:outerShdw blurRad="50800" dist="19050" dir="5400000" algn="bl" rotWithShape="0">
               <a:srgbClr val="000000">
                 <a:alpha val="12000"/>
               </a:srgbClr>
@@ -1989,7 +1777,7 @@
           <a:bodyPr wrap="square" lIns="0" tIns="0" rIns="0" bIns="0" rtlCol="0" anchor="t"/>
           <a:lstStyle/>
           <a:p>
-            <a:pPr algn="ctr" indent="0" marL="0">
+            <a:pPr marL="0" indent="0" algn="ctr">
               <a:buNone/>
             </a:pPr>
             <a:r>
@@ -2028,7 +1816,7 @@
           <a:bodyPr wrap="square" lIns="0" tIns="0" rIns="0" bIns="0" rtlCol="0" anchor="t"/>
           <a:lstStyle/>
           <a:p>
-            <a:pPr algn="ctr" indent="0" marL="0">
+            <a:pPr marL="0" indent="0" algn="ctr">
               <a:buNone/>
             </a:pPr>
             <a:r>
@@ -2045,7 +1833,7 @@
             <a:endParaRPr lang="en-US" sz="1100" dirty="0"/>
           </a:p>
           <a:p>
-            <a:pPr algn="ctr" indent="0" marL="0">
+            <a:pPr marL="0" indent="0" algn="ctr">
               <a:buNone/>
             </a:pPr>
             <a:r>
@@ -2113,7 +1901,7 @@
             <a:prstDash val="solid"/>
           </a:ln>
           <a:effectLst>
-            <a:outerShdw sx="100000" sy="100000" kx="0" ky="0" algn="bl" rotWithShape="0" blurRad="50800" dist="19050" dir="5400000">
+            <a:outerShdw blurRad="50800" dist="19050" dir="5400000" algn="bl" rotWithShape="0">
               <a:srgbClr val="000000">
                 <a:alpha val="12000"/>
               </a:srgbClr>
@@ -2142,7 +1930,7 @@
           <a:bodyPr wrap="square" lIns="0" tIns="0" rIns="0" bIns="0" rtlCol="0" anchor="t"/>
           <a:lstStyle/>
           <a:p>
-            <a:pPr algn="ctr" indent="0" marL="0">
+            <a:pPr marL="0" indent="0" algn="ctr">
               <a:buNone/>
             </a:pPr>
             <a:r>
@@ -2181,7 +1969,7 @@
           <a:bodyPr wrap="square" lIns="0" tIns="0" rIns="0" bIns="0" rtlCol="0" anchor="t"/>
           <a:lstStyle/>
           <a:p>
-            <a:pPr algn="ctr" indent="0" marL="0">
+            <a:pPr marL="0" indent="0" algn="ctr">
               <a:buNone/>
             </a:pPr>
             <a:r>
@@ -2198,7 +1986,7 @@
             <a:endParaRPr lang="en-US" sz="1100" dirty="0"/>
           </a:p>
           <a:p>
-            <a:pPr algn="ctr" indent="0" marL="0">
+            <a:pPr marL="0" indent="0" algn="ctr">
               <a:buNone/>
             </a:pPr>
             <a:r>
@@ -2266,7 +2054,7 @@
             <a:prstDash val="solid"/>
           </a:ln>
           <a:effectLst>
-            <a:outerShdw sx="100000" sy="100000" kx="0" ky="0" algn="bl" rotWithShape="0" blurRad="50800" dist="19050" dir="5400000">
+            <a:outerShdw blurRad="50800" dist="19050" dir="5400000" algn="bl" rotWithShape="0">
               <a:srgbClr val="000000">
                 <a:alpha val="12000"/>
               </a:srgbClr>
@@ -2295,7 +2083,7 @@
           <a:bodyPr wrap="square" lIns="0" tIns="0" rIns="0" bIns="0" rtlCol="0" anchor="t"/>
           <a:lstStyle/>
           <a:p>
-            <a:pPr algn="ctr" indent="0" marL="0">
+            <a:pPr marL="0" indent="0" algn="ctr">
               <a:buNone/>
             </a:pPr>
             <a:r>
@@ -2334,7 +2122,7 @@
           <a:bodyPr wrap="square" lIns="0" tIns="0" rIns="0" bIns="0" rtlCol="0" anchor="t"/>
           <a:lstStyle/>
           <a:p>
-            <a:pPr algn="ctr" indent="0" marL="0">
+            <a:pPr marL="0" indent="0" algn="ctr">
               <a:buNone/>
             </a:pPr>
             <a:r>
@@ -2351,7 +2139,7 @@
             <a:endParaRPr lang="en-US" sz="1100" dirty="0"/>
           </a:p>
           <a:p>
-            <a:pPr algn="ctr" indent="0" marL="0">
+            <a:pPr marL="0" indent="0" algn="ctr">
               <a:buNone/>
             </a:pPr>
             <a:r>
@@ -2419,7 +2207,7 @@
             <a:prstDash val="solid"/>
           </a:ln>
           <a:effectLst>
-            <a:outerShdw sx="100000" sy="100000" kx="0" ky="0" algn="bl" rotWithShape="0" blurRad="50800" dist="19050" dir="5400000">
+            <a:outerShdw blurRad="50800" dist="19050" dir="5400000" algn="bl" rotWithShape="0">
               <a:srgbClr val="000000">
                 <a:alpha val="12000"/>
               </a:srgbClr>
@@ -2448,7 +2236,7 @@
           <a:bodyPr wrap="square" lIns="0" tIns="0" rIns="0" bIns="0" rtlCol="0" anchor="t"/>
           <a:lstStyle/>
           <a:p>
-            <a:pPr algn="ctr" indent="0" marL="0">
+            <a:pPr marL="0" indent="0" algn="ctr">
               <a:buNone/>
             </a:pPr>
             <a:r>
@@ -2487,7 +2275,7 @@
           <a:bodyPr wrap="square" lIns="0" tIns="0" rIns="0" bIns="0" rtlCol="0" anchor="t"/>
           <a:lstStyle/>
           <a:p>
-            <a:pPr algn="ctr" indent="0" marL="0">
+            <a:pPr marL="0" indent="0" algn="ctr">
               <a:buNone/>
             </a:pPr>
             <a:r>
@@ -2504,7 +2292,7 @@
             <a:endParaRPr lang="en-US" sz="1100" dirty="0"/>
           </a:p>
           <a:p>
-            <a:pPr algn="ctr" indent="0" marL="0">
+            <a:pPr marL="0" indent="0" algn="ctr">
               <a:buNone/>
             </a:pPr>
             <a:r>
@@ -2572,7 +2360,7 @@
             <a:prstDash val="solid"/>
           </a:ln>
           <a:effectLst>
-            <a:outerShdw sx="100000" sy="100000" kx="0" ky="0" algn="bl" rotWithShape="0" blurRad="50800" dist="19050" dir="5400000">
+            <a:outerShdw blurRad="50800" dist="19050" dir="5400000" algn="bl" rotWithShape="0">
               <a:srgbClr val="000000">
                 <a:alpha val="12000"/>
               </a:srgbClr>
@@ -2601,7 +2389,7 @@
           <a:bodyPr wrap="square" lIns="0" tIns="0" rIns="0" bIns="0" rtlCol="0" anchor="t"/>
           <a:lstStyle/>
           <a:p>
-            <a:pPr algn="ctr" indent="0" marL="0">
+            <a:pPr marL="0" indent="0" algn="ctr">
               <a:buNone/>
             </a:pPr>
             <a:r>
@@ -2640,7 +2428,7 @@
           <a:bodyPr wrap="square" lIns="0" tIns="0" rIns="0" bIns="0" rtlCol="0" anchor="t"/>
           <a:lstStyle/>
           <a:p>
-            <a:pPr algn="ctr" indent="0" marL="0">
+            <a:pPr marL="0" indent="0" algn="ctr">
               <a:buNone/>
             </a:pPr>
             <a:r>
@@ -2657,7 +2445,7 @@
             <a:endParaRPr lang="en-US" sz="1100" dirty="0"/>
           </a:p>
           <a:p>
-            <a:pPr algn="ctr" indent="0" marL="0">
+            <a:pPr marL="0" indent="0" algn="ctr">
               <a:buNone/>
             </a:pPr>
             <a:r>
@@ -2725,7 +2513,7 @@
             <a:prstDash val="solid"/>
           </a:ln>
           <a:effectLst>
-            <a:outerShdw sx="100000" sy="100000" kx="0" ky="0" algn="bl" rotWithShape="0" blurRad="50800" dist="19050" dir="5400000">
+            <a:outerShdw blurRad="50800" dist="19050" dir="5400000" algn="bl" rotWithShape="0">
               <a:srgbClr val="000000">
                 <a:alpha val="12000"/>
               </a:srgbClr>
@@ -2754,7 +2542,7 @@
           <a:bodyPr wrap="square" lIns="0" tIns="0" rIns="0" bIns="0" rtlCol="0" anchor="t"/>
           <a:lstStyle/>
           <a:p>
-            <a:pPr algn="ctr" indent="0" marL="0">
+            <a:pPr marL="0" indent="0" algn="ctr">
               <a:buNone/>
             </a:pPr>
             <a:r>
@@ -2793,7 +2581,7 @@
           <a:bodyPr wrap="square" lIns="0" tIns="0" rIns="0" bIns="0" rtlCol="0" anchor="t"/>
           <a:lstStyle/>
           <a:p>
-            <a:pPr algn="ctr" indent="0" marL="0">
+            <a:pPr marL="0" indent="0" algn="ctr">
               <a:buNone/>
             </a:pPr>
             <a:r>
@@ -2810,7 +2598,7 @@
             <a:endParaRPr lang="en-US" sz="1100" dirty="0"/>
           </a:p>
           <a:p>
-            <a:pPr algn="ctr" indent="0" marL="0">
+            <a:pPr marL="0" indent="0" algn="ctr">
               <a:buNone/>
             </a:pPr>
             <a:r>
@@ -2849,7 +2637,7 @@
           <a:bodyPr wrap="square" lIns="0" tIns="0" rIns="0" bIns="0" rtlCol="0" anchor="t"/>
           <a:lstStyle/>
           <a:p>
-            <a:pPr algn="ctr" indent="0" marL="0">
+            <a:pPr marL="0" indent="0" algn="ctr">
               <a:buNone/>
             </a:pPr>
             <a:r>
@@ -2888,7 +2676,7 @@
           <a:bodyPr wrap="square" lIns="0" tIns="0" rIns="0" bIns="0" rtlCol="0" anchor="t"/>
           <a:lstStyle/>
           <a:p>
-            <a:pPr algn="ctr" indent="0" marL="0">
+            <a:pPr marL="0" indent="0" algn="ctr">
               <a:buNone/>
             </a:pPr>
             <a:r>
@@ -2932,7 +2720,7 @@
             <a:prstDash val="solid"/>
           </a:ln>
           <a:effectLst>
-            <a:outerShdw sx="100000" sy="100000" kx="0" ky="0" algn="bl" rotWithShape="0" blurRad="50800" dist="19050" dir="5400000">
+            <a:outerShdw blurRad="50800" dist="19050" dir="5400000" algn="bl" rotWithShape="0">
               <a:srgbClr val="000000">
                 <a:alpha val="12000"/>
               </a:srgbClr>
@@ -2961,7 +2749,7 @@
           <a:bodyPr wrap="square" lIns="0" tIns="0" rIns="0" bIns="0" rtlCol="0" anchor="t"/>
           <a:lstStyle/>
           <a:p>
-            <a:pPr indent="0" marL="0">
+            <a:pPr marL="0" indent="0">
               <a:buNone/>
             </a:pPr>
             <a:r>
@@ -2975,9 +2763,6 @@
               </a:rPr>
               <a:t>mission/clues → my planner: </a:t>
             </a:r>
-            <a:pPr indent="0" marL="0">
-              <a:buNone/>
-            </a:pPr>
             <a:r>
               <a:rPr lang="en-US" sz="1400" dirty="0">
                 <a:solidFill>
@@ -2989,9 +2774,6 @@
               </a:rPr>
               <a:t>inspect_closer → hover over the clue · converge_search → circle around the centre · ignore / log_only → nothing flies. </a:t>
             </a:r>
-            <a:pPr indent="0" marL="0">
-              <a:buNone/>
-            </a:pPr>
             <a:r>
               <a:rPr lang="en-US" sz="1400" b="1" dirty="0">
                 <a:solidFill>
@@ -3009,7 +2791,7 @@
       </p:sp>
       <p:sp>
         <p:nvSpPr>
-          <p:cNvPr id="25" name="Slide Number Placeholder 0"/>
+          <p:cNvPr id="30" name="Slide Number Placeholder 0"/>
           <p:cNvSpPr>
             <a:spLocks noGrp="1"/>
           </p:cNvSpPr>
@@ -3027,7 +2809,7 @@
           </a:prstGeom>
           <a:extLst>
             <a:ext uri="{C572A759-6A51-4108-AA02-DFA0A04FC94B}">
-              <ma14:wrappingTextBoxFlag xmlns:ma14="http://schemas.microsoft.com/office/mac/drawingml/2011/main" val="0"/>
+              <ma14:wrappingTextBoxFlag xmlns:ma14="http://schemas.microsoft.com/office/mac/drawingml/2011/main" xmlns="" val="0"/>
             </a:ext>
           </a:extLst>
         </p:spPr>
@@ -3048,7 +2830,7 @@
           <a:p>
             <a:pPr algn="l"/>
             <a:fld id="{F7021451-1387-4CA6-816F-3879F97B5CBC}" type="slidenum">
-              <a:rPr b="0" lang="en-US"/>
+              <a:rPr lang="en-US" b="0"/>
               <a:t>2</a:t>
             </a:fld>
             <a:endParaRPr lang="en-US"/>
@@ -3101,7 +2883,7 @@
           <a:bodyPr wrap="square" lIns="0" tIns="0" rIns="0" bIns="0" rtlCol="0" anchor="ctr"/>
           <a:lstStyle/>
           <a:p>
-            <a:pPr indent="0" marL="0">
+            <a:pPr marL="0" indent="0">
               <a:buNone/>
             </a:pPr>
             <a:r>
@@ -3140,7 +2922,7 @@
           <a:bodyPr wrap="square" lIns="0" tIns="0" rIns="0" bIns="0" rtlCol="0" anchor="t"/>
           <a:lstStyle/>
           <a:p>
-            <a:pPr indent="0" marL="0">
+            <a:pPr marL="0" indent="0">
               <a:buNone/>
             </a:pPr>
             <a:r>
@@ -3155,9 +2937,6 @@
               <a:t>Description, written before drawing
 </a:t>
             </a:r>
-            <a:pPr indent="0" marL="0">
-              <a:buNone/>
-            </a:pPr>
             <a:r>
               <a:rPr lang="en-US" sz="1400" dirty="0">
                 <a:solidFill>
@@ -3194,7 +2973,7 @@
           <a:bodyPr wrap="square" lIns="0" tIns="0" rIns="0" bIns="0" rtlCol="0" anchor="t"/>
           <a:lstStyle/>
           <a:p>
-            <a:pPr indent="0" marL="0">
+            <a:pPr marL="0" indent="0">
               <a:buNone/>
             </a:pPr>
             <a:r>
@@ -3209,9 +2988,6 @@
               <a:t>Why each decoy
 </a:t>
             </a:r>
-            <a:pPr indent="0" marL="0">
-              <a:buNone/>
-            </a:pPr>
             <a:r>
               <a:rPr lang="en-US" sz="1400" dirty="0">
                 <a:solidFill>
@@ -3229,15 +3005,15 @@
       </p:sp>
       <p:pic>
         <p:nvPicPr>
-          <p:cNvPr id="5" name="Image 0" descr="C:\Users\Yitong\AppData\Local\Temp\claude\--wsl-localhost-Ubuntu-home-yitong-uav-native-ai\5626ac00-b96f-4523-b66d-3cae6d4f4d7e\scratchpad\deck\e01.png">    </p:cNvPr>
+          <p:cNvPr id="5" name="Image 0" descr="C:\Users\Yitong\AppData\Local\Temp\claude\--wsl-localhost-Ubuntu-home-yitong-uav-native-ai\5626ac00-b96f-4523-b66d-3cae6d4f4d7e\scratchpad\deck\e01.png"/>
           <p:cNvPicPr>
             <a:picLocks noChangeAspect="1"/>
           </p:cNvPicPr>
           <p:nvPr/>
         </p:nvPicPr>
         <p:blipFill>
-          <a:blip r:embed="rId1"/>
-          <a:srcRect l="0" r="0" t="0" b="0"/>
+          <a:blip r:embed="rId3"/>
+          <a:srcRect/>
           <a:stretch/>
         </p:blipFill>
         <p:spPr>
@@ -3296,7 +3072,7 @@
           <a:bodyPr wrap="square" lIns="0" tIns="0" rIns="0" bIns="0" rtlCol="0" anchor="t"/>
           <a:lstStyle/>
           <a:p>
-            <a:pPr indent="0" marL="0">
+            <a:pPr marL="0" indent="0">
               <a:buNone/>
             </a:pPr>
             <a:r>
@@ -3316,15 +3092,15 @@
       </p:sp>
       <p:pic>
         <p:nvPicPr>
-          <p:cNvPr id="8" name="Image 1" descr="C:\Users\Yitong\AppData\Local\Temp\claude\--wsl-localhost-Ubuntu-home-yitong-uav-native-ai\5626ac00-b96f-4523-b66d-3cae6d4f4d7e\scratchpad\deck\e02.png">    </p:cNvPr>
+          <p:cNvPr id="8" name="Image 1" descr="C:\Users\Yitong\AppData\Local\Temp\claude\--wsl-localhost-Ubuntu-home-yitong-uav-native-ai\5626ac00-b96f-4523-b66d-3cae6d4f4d7e\scratchpad\deck\e02.png"/>
           <p:cNvPicPr>
             <a:picLocks noChangeAspect="1"/>
           </p:cNvPicPr>
           <p:nvPr/>
         </p:nvPicPr>
         <p:blipFill>
-          <a:blip r:embed="rId2"/>
-          <a:srcRect l="0" r="0" t="0" b="0"/>
+          <a:blip r:embed="rId4"/>
+          <a:srcRect/>
           <a:stretch/>
         </p:blipFill>
         <p:spPr>
@@ -3383,7 +3159,7 @@
           <a:bodyPr wrap="square" lIns="0" tIns="0" rIns="0" bIns="0" rtlCol="0" anchor="t"/>
           <a:lstStyle/>
           <a:p>
-            <a:pPr indent="0" marL="0">
+            <a:pPr marL="0" indent="0">
               <a:buNone/>
             </a:pPr>
             <a:r>
@@ -3403,15 +3179,15 @@
       </p:sp>
       <p:pic>
         <p:nvPicPr>
-          <p:cNvPr id="11" name="Image 2" descr="C:\Users\Yitong\AppData\Local\Temp\claude\--wsl-localhost-Ubuntu-home-yitong-uav-native-ai\5626ac00-b96f-4523-b66d-3cae6d4f4d7e\scratchpad\deck\e03.png">    </p:cNvPr>
+          <p:cNvPr id="11" name="Image 2" descr="C:\Users\Yitong\AppData\Local\Temp\claude\--wsl-localhost-Ubuntu-home-yitong-uav-native-ai\5626ac00-b96f-4523-b66d-3cae6d4f4d7e\scratchpad\deck\e03.png"/>
           <p:cNvPicPr>
             <a:picLocks noChangeAspect="1"/>
           </p:cNvPicPr>
           <p:nvPr/>
         </p:nvPicPr>
         <p:blipFill>
-          <a:blip r:embed="rId3"/>
-          <a:srcRect l="0" r="0" t="0" b="0"/>
+          <a:blip r:embed="rId5"/>
+          <a:srcRect/>
           <a:stretch/>
         </p:blipFill>
         <p:spPr>
@@ -3470,7 +3246,7 @@
           <a:bodyPr wrap="square" lIns="0" tIns="0" rIns="0" bIns="0" rtlCol="0" anchor="t"/>
           <a:lstStyle/>
           <a:p>
-            <a:pPr indent="0" marL="0">
+            <a:pPr marL="0" indent="0">
               <a:buNone/>
             </a:pPr>
             <a:r>
@@ -3490,15 +3266,15 @@
       </p:sp>
       <p:pic>
         <p:nvPicPr>
-          <p:cNvPr id="14" name="Image 3" descr="C:\Users\Yitong\AppData\Local\Temp\claude\--wsl-localhost-Ubuntu-home-yitong-uav-native-ai\5626ac00-b96f-4523-b66d-3cae6d4f4d7e\scratchpad\deck\e04.png">    </p:cNvPr>
+          <p:cNvPr id="14" name="Image 3" descr="C:\Users\Yitong\AppData\Local\Temp\claude\--wsl-localhost-Ubuntu-home-yitong-uav-native-ai\5626ac00-b96f-4523-b66d-3cae6d4f4d7e\scratchpad\deck\e04.png"/>
           <p:cNvPicPr>
             <a:picLocks noChangeAspect="1"/>
           </p:cNvPicPr>
           <p:nvPr/>
         </p:nvPicPr>
         <p:blipFill>
-          <a:blip r:embed="rId4"/>
-          <a:srcRect l="0" r="0" t="0" b="0"/>
+          <a:blip r:embed="rId6"/>
+          <a:srcRect/>
           <a:stretch/>
         </p:blipFill>
         <p:spPr>
@@ -3557,7 +3333,7 @@
           <a:bodyPr wrap="square" lIns="0" tIns="0" rIns="0" bIns="0" rtlCol="0" anchor="t"/>
           <a:lstStyle/>
           <a:p>
-            <a:pPr indent="0" marL="0">
+            <a:pPr marL="0" indent="0">
               <a:buNone/>
             </a:pPr>
             <a:r>
@@ -3577,15 +3353,15 @@
       </p:sp>
       <p:pic>
         <p:nvPicPr>
-          <p:cNvPr id="17" name="Image 4" descr="C:\Users\Yitong\AppData\Local\Temp\claude\--wsl-localhost-Ubuntu-home-yitong-uav-native-ai\5626ac00-b96f-4523-b66d-3cae6d4f4d7e\scratchpad\deck\e05.png">    </p:cNvPr>
+          <p:cNvPr id="17" name="Image 4" descr="C:\Users\Yitong\AppData\Local\Temp\claude\--wsl-localhost-Ubuntu-home-yitong-uav-native-ai\5626ac00-b96f-4523-b66d-3cae6d4f4d7e\scratchpad\deck\e05.png"/>
           <p:cNvPicPr>
             <a:picLocks noChangeAspect="1"/>
           </p:cNvPicPr>
           <p:nvPr/>
         </p:nvPicPr>
         <p:blipFill>
-          <a:blip r:embed="rId5"/>
-          <a:srcRect l="0" r="0" t="0" b="0"/>
+          <a:blip r:embed="rId7"/>
+          <a:srcRect/>
           <a:stretch/>
         </p:blipFill>
         <p:spPr>
@@ -3644,7 +3420,7 @@
           <a:bodyPr wrap="square" lIns="0" tIns="0" rIns="0" bIns="0" rtlCol="0" anchor="t"/>
           <a:lstStyle/>
           <a:p>
-            <a:pPr indent="0" marL="0">
+            <a:pPr marL="0" indent="0">
               <a:buNone/>
             </a:pPr>
             <a:r>
@@ -3664,15 +3440,15 @@
       </p:sp>
       <p:pic>
         <p:nvPicPr>
-          <p:cNvPr id="20" name="Image 5" descr="C:\Users\Yitong\AppData\Local\Temp\claude\--wsl-localhost-Ubuntu-home-yitong-uav-native-ai\5626ac00-b96f-4523-b66d-3cae6d4f4d7e\scratchpad\deck\e06.png">    </p:cNvPr>
+          <p:cNvPr id="20" name="Image 5" descr="C:\Users\Yitong\AppData\Local\Temp\claude\--wsl-localhost-Ubuntu-home-yitong-uav-native-ai\5626ac00-b96f-4523-b66d-3cae6d4f4d7e\scratchpad\deck\e06.png"/>
           <p:cNvPicPr>
             <a:picLocks noChangeAspect="1"/>
           </p:cNvPicPr>
           <p:nvPr/>
         </p:nvPicPr>
         <p:blipFill>
-          <a:blip r:embed="rId6"/>
-          <a:srcRect l="0" r="0" t="0" b="0"/>
+          <a:blip r:embed="rId8"/>
+          <a:srcRect/>
           <a:stretch/>
         </p:blipFill>
         <p:spPr>
@@ -3731,7 +3507,7 @@
           <a:bodyPr wrap="square" lIns="0" tIns="0" rIns="0" bIns="0" rtlCol="0" anchor="t"/>
           <a:lstStyle/>
           <a:p>
-            <a:pPr indent="0" marL="0">
+            <a:pPr marL="0" indent="0">
               <a:buNone/>
             </a:pPr>
             <a:r>
@@ -3769,7 +3545,7 @@
           </a:prstGeom>
           <a:extLst>
             <a:ext uri="{C572A759-6A51-4108-AA02-DFA0A04FC94B}">
-              <ma14:wrappingTextBoxFlag xmlns:ma14="http://schemas.microsoft.com/office/mac/drawingml/2011/main" val="0"/>
+              <ma14:wrappingTextBoxFlag xmlns:ma14="http://schemas.microsoft.com/office/mac/drawingml/2011/main" xmlns="" val="0"/>
             </a:ext>
           </a:extLst>
         </p:spPr>
@@ -3790,7 +3566,7 @@
           <a:p>
             <a:pPr algn="l"/>
             <a:fld id="{F7021451-1387-4CA6-816F-3879F97B5CBC}" type="slidenum">
-              <a:rPr b="0" lang="en-US"/>
+              <a:rPr lang="en-US" b="0"/>
               <a:t>3</a:t>
             </a:fld>
             <a:endParaRPr lang="en-US"/>
@@ -3843,7 +3619,7 @@
           <a:bodyPr wrap="square" lIns="0" tIns="0" rIns="0" bIns="0" rtlCol="0" anchor="ctr"/>
           <a:lstStyle/>
           <a:p>
-            <a:pPr indent="0" marL="0">
+            <a:pPr marL="0" indent="0">
               <a:buNone/>
             </a:pPr>
             <a:r>
@@ -3887,7 +3663,7 @@
             <a:prstDash val="solid"/>
           </a:ln>
           <a:effectLst>
-            <a:outerShdw sx="100000" sy="100000" kx="0" ky="0" algn="bl" rotWithShape="0" blurRad="50800" dist="19050" dir="5400000">
+            <a:outerShdw blurRad="50800" dist="19050" dir="5400000" algn="bl" rotWithShape="0">
               <a:srgbClr val="000000">
                 <a:alpha val="12000"/>
               </a:srgbClr>
@@ -3916,7 +3692,7 @@
           <a:bodyPr wrap="square" lIns="0" tIns="0" rIns="0" bIns="0" rtlCol="0" anchor="t"/>
           <a:lstStyle/>
           <a:p>
-            <a:pPr algn="ctr" indent="0" marL="0">
+            <a:pPr marL="0" indent="0" algn="ctr">
               <a:buNone/>
             </a:pPr>
             <a:r>
@@ -3955,7 +3731,7 @@
           <a:bodyPr wrap="square" lIns="0" tIns="0" rIns="0" bIns="0" rtlCol="0" anchor="t"/>
           <a:lstStyle/>
           <a:p>
-            <a:pPr algn="ctr" indent="0" marL="0">
+            <a:pPr marL="0" indent="0" algn="ctr">
               <a:buNone/>
             </a:pPr>
             <a:r>
@@ -3972,7 +3748,7 @@
             <a:endParaRPr lang="en-US" sz="1300" dirty="0"/>
           </a:p>
           <a:p>
-            <a:pPr algn="ctr" indent="0" marL="0">
+            <a:pPr marL="0" indent="0" algn="ctr">
               <a:buNone/>
             </a:pPr>
             <a:r>
@@ -4016,7 +3792,7 @@
             <a:prstDash val="solid"/>
           </a:ln>
           <a:effectLst>
-            <a:outerShdw sx="100000" sy="100000" kx="0" ky="0" algn="bl" rotWithShape="0" blurRad="50800" dist="19050" dir="5400000">
+            <a:outerShdw blurRad="50800" dist="19050" dir="5400000" algn="bl" rotWithShape="0">
               <a:srgbClr val="000000">
                 <a:alpha val="12000"/>
               </a:srgbClr>
@@ -4045,7 +3821,7 @@
           <a:bodyPr wrap="square" lIns="0" tIns="0" rIns="0" bIns="0" rtlCol="0" anchor="t"/>
           <a:lstStyle/>
           <a:p>
-            <a:pPr algn="ctr" indent="0" marL="0">
+            <a:pPr marL="0" indent="0" algn="ctr">
               <a:buNone/>
             </a:pPr>
             <a:r>
@@ -4084,7 +3860,7 @@
           <a:bodyPr wrap="square" lIns="0" tIns="0" rIns="0" bIns="0" rtlCol="0" anchor="t"/>
           <a:lstStyle/>
           <a:p>
-            <a:pPr algn="ctr" indent="0" marL="0">
+            <a:pPr marL="0" indent="0" algn="ctr">
               <a:buNone/>
             </a:pPr>
             <a:r>
@@ -4101,7 +3877,7 @@
             <a:endParaRPr lang="en-US" sz="1300" dirty="0"/>
           </a:p>
           <a:p>
-            <a:pPr algn="ctr" indent="0" marL="0">
+            <a:pPr marL="0" indent="0" algn="ctr">
               <a:buNone/>
             </a:pPr>
             <a:r>
@@ -4145,7 +3921,7 @@
             <a:prstDash val="solid"/>
           </a:ln>
           <a:effectLst>
-            <a:outerShdw sx="100000" sy="100000" kx="0" ky="0" algn="bl" rotWithShape="0" blurRad="50800" dist="19050" dir="5400000">
+            <a:outerShdw blurRad="50800" dist="19050" dir="5400000" algn="bl" rotWithShape="0">
               <a:srgbClr val="000000">
                 <a:alpha val="12000"/>
               </a:srgbClr>
@@ -4174,7 +3950,7 @@
           <a:bodyPr wrap="square" lIns="0" tIns="0" rIns="0" bIns="0" rtlCol="0" anchor="t"/>
           <a:lstStyle/>
           <a:p>
-            <a:pPr algn="ctr" indent="0" marL="0">
+            <a:pPr marL="0" indent="0" algn="ctr">
               <a:buNone/>
             </a:pPr>
             <a:r>
@@ -4213,7 +3989,7 @@
           <a:bodyPr wrap="square" lIns="0" tIns="0" rIns="0" bIns="0" rtlCol="0" anchor="t"/>
           <a:lstStyle/>
           <a:p>
-            <a:pPr algn="ctr" indent="0" marL="0">
+            <a:pPr marL="0" indent="0" algn="ctr">
               <a:buNone/>
             </a:pPr>
             <a:r>
@@ -4230,7 +4006,7 @@
             <a:endParaRPr lang="en-US" sz="1300" dirty="0"/>
           </a:p>
           <a:p>
-            <a:pPr algn="ctr" indent="0" marL="0">
+            <a:pPr marL="0" indent="0" algn="ctr">
               <a:buNone/>
             </a:pPr>
             <a:r>
@@ -4274,7 +4050,7 @@
             <a:prstDash val="solid"/>
           </a:ln>
           <a:effectLst>
-            <a:outerShdw sx="100000" sy="100000" kx="0" ky="0" algn="bl" rotWithShape="0" blurRad="50800" dist="19050" dir="5400000">
+            <a:outerShdw blurRad="50800" dist="19050" dir="5400000" algn="bl" rotWithShape="0">
               <a:srgbClr val="000000">
                 <a:alpha val="12000"/>
               </a:srgbClr>
@@ -4303,7 +4079,7 @@
           <a:bodyPr wrap="square" lIns="0" tIns="0" rIns="0" bIns="0" rtlCol="0" anchor="t"/>
           <a:lstStyle/>
           <a:p>
-            <a:pPr algn="ctr" indent="0" marL="0">
+            <a:pPr marL="0" indent="0" algn="ctr">
               <a:buNone/>
             </a:pPr>
             <a:r>
@@ -4342,7 +4118,7 @@
           <a:bodyPr wrap="square" lIns="0" tIns="0" rIns="0" bIns="0" rtlCol="0" anchor="t"/>
           <a:lstStyle/>
           <a:p>
-            <a:pPr algn="ctr" indent="0" marL="0">
+            <a:pPr marL="0" indent="0" algn="ctr">
               <a:buNone/>
             </a:pPr>
             <a:r>
@@ -4359,7 +4135,7 @@
             <a:endParaRPr lang="en-US" sz="1300" dirty="0"/>
           </a:p>
           <a:p>
-            <a:pPr algn="ctr" indent="0" marL="0">
+            <a:pPr marL="0" indent="0" algn="ctr">
               <a:buNone/>
             </a:pPr>
             <a:r>
@@ -4398,7 +4174,7 @@
           <a:bodyPr wrap="square" lIns="0" tIns="0" rIns="0" bIns="0" rtlCol="0" anchor="t"/>
           <a:lstStyle/>
           <a:p>
-            <a:pPr indent="0" marL="0">
+            <a:pPr marL="0" indent="0">
               <a:buNone/>
             </a:pPr>
             <a:r>
@@ -4412,9 +4188,6 @@
               </a:rPr>
               <a:t>The only disagreement: </a:t>
             </a:r>
-            <a:pPr indent="0" marL="0">
-              <a:buNone/>
-            </a:pPr>
             <a:r>
               <a:rPr lang="en-US" sz="1500" dirty="0">
                 <a:solidFill>
@@ -4427,9 +4200,6 @@
               <a:t>Lily's shoe went log_only, log_only, ignore (both acceptable). Closer looks: 8, all asked for by Describe. Code guard overrides: 0.
 </a:t>
             </a:r>
-            <a:pPr indent="0" marL="0">
-              <a:buNone/>
-            </a:pPr>
             <a:r>
               <a:rPr lang="en-US" sz="1500" b="1" dirty="0">
                 <a:solidFill>
@@ -4441,9 +4211,6 @@
               </a:rPr>
               <a:t>But these renders are sharp. </a:t>
             </a:r>
-            <a:pPr indent="0" marL="0">
-              <a:buNone/>
-            </a:pPr>
             <a:r>
               <a:rPr lang="en-US" sz="1500" dirty="0">
                 <a:solidFill>
@@ -4479,7 +4246,7 @@
           </a:prstGeom>
           <a:extLst>
             <a:ext uri="{C572A759-6A51-4108-AA02-DFA0A04FC94B}">
-              <ma14:wrappingTextBoxFlag xmlns:ma14="http://schemas.microsoft.com/office/mac/drawingml/2011/main" val="0"/>
+              <ma14:wrappingTextBoxFlag xmlns:ma14="http://schemas.microsoft.com/office/mac/drawingml/2011/main" xmlns="" val="0"/>
             </a:ext>
           </a:extLst>
         </p:spPr>
@@ -4500,7 +4267,7 @@
           <a:p>
             <a:pPr algn="l"/>
             <a:fld id="{F7021451-1387-4CA6-816F-3879F97B5CBC}" type="slidenum">
-              <a:rPr b="0" lang="en-US"/>
+              <a:rPr lang="en-US" b="0"/>
               <a:t>4</a:t>
             </a:fld>
             <a:endParaRPr lang="en-US"/>
@@ -4553,7 +4320,7 @@
           <a:bodyPr wrap="square" lIns="0" tIns="0" rIns="0" bIns="0" rtlCol="0" anchor="ctr"/>
           <a:lstStyle/>
           <a:p>
-            <a:pPr indent="0" marL="0">
+            <a:pPr marL="0" indent="0">
               <a:buNone/>
             </a:pPr>
             <a:r>
@@ -4573,133 +4340,7 @@
       </p:sp>
       <p:pic>
         <p:nvPicPr>
-          <p:cNvPr id="3" name="Image 0" descr="C:\Users\Yitong\AppData\Local\Temp\claude\--wsl-localhost-Ubuntu-home-yitong-uav-native-ai\5626ac00-b96f-4523-b66d-3cae6d4f4d7e\scratchpad\deck\e01.png">    </p:cNvPr>
-          <p:cNvPicPr>
-            <a:picLocks noChangeAspect="1"/>
-          </p:cNvPicPr>
-          <p:nvPr/>
-        </p:nvPicPr>
-        <p:blipFill>
-          <a:blip r:embed="rId1"/>
-          <a:stretch>
-            <a:fillRect/>
-          </a:stretch>
-        </p:blipFill>
-        <p:spPr>
-          <a:xfrm>
-            <a:off x="457200" y="1051560"/>
-            <a:ext cx="1005840" cy="1005840"/>
-          </a:xfrm>
-          <a:prstGeom prst="rect">
-            <a:avLst/>
-          </a:prstGeom>
-        </p:spPr>
-      </p:pic>
-      <p:sp>
-        <p:nvSpPr>
-          <p:cNvPr id="4" name="Text 1"/>
-          <p:cNvSpPr txBox="1"/>
-          <p:nvPr/>
-        </p:nvSpPr>
-        <p:spPr>
-          <a:xfrm>
-            <a:off x="1554480" y="1399032"/>
-            <a:ext cx="1188720" cy="320040"/>
-          </a:xfrm>
-          <a:prstGeom prst="rect">
-            <a:avLst/>
-          </a:prstGeom>
-          <a:noFill/>
-          <a:ln/>
-        </p:spPr>
-        <p:txBody>
-          <a:bodyPr wrap="square" lIns="0" tIns="0" rIns="0" bIns="0" rtlCol="0" anchor="t"/>
-          <a:lstStyle/>
-          <a:p>
-            <a:pPr indent="0" marL="0">
-              <a:buNone/>
-            </a:pPr>
-            <a:r>
-              <a:rPr lang="en-US" sz="1200" dirty="0">
-                <a:solidFill>
-                  <a:srgbClr val="2E3A48"/>
-                </a:solidFill>
-                <a:latin typeface="Calibri" pitchFamily="34" charset="0"/>
-                <a:ea typeface="Calibri" pitchFamily="34" charset="-122"/>
-                <a:cs typeface="Calibri" pitchFamily="34" charset="-120"/>
-              </a:rPr>
-              <a:t>offline render</a:t>
-            </a:r>
-            <a:endParaRPr lang="en-US" sz="1200" dirty="0"/>
-          </a:p>
-        </p:txBody>
-      </p:sp>
-      <p:pic>
-        <p:nvPicPr>
-          <p:cNvPr id="5" name="Image 1" descr="C:\Users\Yitong\AppData\Local\Temp\claude\--wsl-localhost-Ubuntu-home-yitong-uav-native-ai\5626ac00-b96f-4523-b66d-3cae6d4f4d7e\scratchpad\deck\e01-flight.png">    </p:cNvPr>
-          <p:cNvPicPr>
-            <a:picLocks noChangeAspect="1"/>
-          </p:cNvPicPr>
-          <p:nvPr/>
-        </p:nvPicPr>
-        <p:blipFill>
-          <a:blip r:embed="rId2"/>
-          <a:stretch>
-            <a:fillRect/>
-          </a:stretch>
-        </p:blipFill>
-        <p:spPr>
-          <a:xfrm>
-            <a:off x="457200" y="2240280"/>
-            <a:ext cx="1005840" cy="1005840"/>
-          </a:xfrm>
-          <a:prstGeom prst="rect">
-            <a:avLst/>
-          </a:prstGeom>
-        </p:spPr>
-      </p:pic>
-      <p:sp>
-        <p:nvSpPr>
-          <p:cNvPr id="6" name="Text 2"/>
-          <p:cNvSpPr txBox="1"/>
-          <p:nvPr/>
-        </p:nvSpPr>
-        <p:spPr>
-          <a:xfrm>
-            <a:off x="1554480" y="2587752"/>
-            <a:ext cx="1188720" cy="320040"/>
-          </a:xfrm>
-          <a:prstGeom prst="rect">
-            <a:avLst/>
-          </a:prstGeom>
-          <a:noFill/>
-          <a:ln/>
-        </p:spPr>
-        <p:txBody>
-          <a:bodyPr wrap="square" lIns="0" tIns="0" rIns="0" bIns="0" rtlCol="0" anchor="t"/>
-          <a:lstStyle/>
-          <a:p>
-            <a:pPr indent="0" marL="0">
-              <a:buNone/>
-            </a:pPr>
-            <a:r>
-              <a:rPr lang="en-US" sz="1200" b="1" dirty="0">
-                <a:solidFill>
-                  <a:srgbClr val="2E3A48"/>
-                </a:solidFill>
-                <a:latin typeface="Calibri" pitchFamily="34" charset="0"/>
-                <a:ea typeface="Calibri" pitchFamily="34" charset="-122"/>
-                <a:cs typeface="Calibri" pitchFamily="34" charset="-120"/>
-              </a:rPr>
-              <a:t>in flight (GUI)</a:t>
-            </a:r>
-            <a:endParaRPr lang="en-US" sz="1200" dirty="0"/>
-          </a:p>
-        </p:txBody>
-      </p:sp>
-      <p:pic>
-        <p:nvPicPr>
-          <p:cNvPr id="7" name="Image 2" descr="C:\Users\Yitong\AppData\Local\Temp\claude\--wsl-localhost-Ubuntu-home-yitong-uav-native-ai\5626ac00-b96f-4523-b66d-3cae6d4f4d7e\scratchpad\deck\e01-zoom.png">    </p:cNvPr>
+          <p:cNvPr id="3" name="Image 0" descr="C:\Users\Yitong\AppData\Local\Temp\claude\--wsl-localhost-Ubuntu-home-yitong-uav-native-ai\5626ac00-b96f-4523-b66d-3cae6d4f4d7e\scratchpad\deck\e01.png"/>
           <p:cNvPicPr>
             <a:picLocks noChangeAspect="1"/>
           </p:cNvPicPr>
@@ -4713,6 +4354,132 @@
         </p:blipFill>
         <p:spPr>
           <a:xfrm>
+            <a:off x="457200" y="1051560"/>
+            <a:ext cx="1005840" cy="1005840"/>
+          </a:xfrm>
+          <a:prstGeom prst="rect">
+            <a:avLst/>
+          </a:prstGeom>
+        </p:spPr>
+      </p:pic>
+      <p:sp>
+        <p:nvSpPr>
+          <p:cNvPr id="4" name="Text 1"/>
+          <p:cNvSpPr txBox="1"/>
+          <p:nvPr/>
+        </p:nvSpPr>
+        <p:spPr>
+          <a:xfrm>
+            <a:off x="1554480" y="1399032"/>
+            <a:ext cx="1188720" cy="320040"/>
+          </a:xfrm>
+          <a:prstGeom prst="rect">
+            <a:avLst/>
+          </a:prstGeom>
+          <a:noFill/>
+          <a:ln/>
+        </p:spPr>
+        <p:txBody>
+          <a:bodyPr wrap="square" lIns="0" tIns="0" rIns="0" bIns="0" rtlCol="0" anchor="t"/>
+          <a:lstStyle/>
+          <a:p>
+            <a:pPr marL="0" indent="0">
+              <a:buNone/>
+            </a:pPr>
+            <a:r>
+              <a:rPr lang="en-US" sz="1200" dirty="0">
+                <a:solidFill>
+                  <a:srgbClr val="2E3A48"/>
+                </a:solidFill>
+                <a:latin typeface="Calibri" pitchFamily="34" charset="0"/>
+                <a:ea typeface="Calibri" pitchFamily="34" charset="-122"/>
+                <a:cs typeface="Calibri" pitchFamily="34" charset="-120"/>
+              </a:rPr>
+              <a:t>offline render</a:t>
+            </a:r>
+            <a:endParaRPr lang="en-US" sz="1200" dirty="0"/>
+          </a:p>
+        </p:txBody>
+      </p:sp>
+      <p:pic>
+        <p:nvPicPr>
+          <p:cNvPr id="5" name="Image 1" descr="C:\Users\Yitong\AppData\Local\Temp\claude\--wsl-localhost-Ubuntu-home-yitong-uav-native-ai\5626ac00-b96f-4523-b66d-3cae6d4f4d7e\scratchpad\deck\e01-flight.png"/>
+          <p:cNvPicPr>
+            <a:picLocks noChangeAspect="1"/>
+          </p:cNvPicPr>
+          <p:nvPr/>
+        </p:nvPicPr>
+        <p:blipFill>
+          <a:blip r:embed="rId4"/>
+          <a:stretch>
+            <a:fillRect/>
+          </a:stretch>
+        </p:blipFill>
+        <p:spPr>
+          <a:xfrm>
+            <a:off x="457200" y="2240280"/>
+            <a:ext cx="1005840" cy="1005840"/>
+          </a:xfrm>
+          <a:prstGeom prst="rect">
+            <a:avLst/>
+          </a:prstGeom>
+        </p:spPr>
+      </p:pic>
+      <p:sp>
+        <p:nvSpPr>
+          <p:cNvPr id="6" name="Text 2"/>
+          <p:cNvSpPr txBox="1"/>
+          <p:nvPr/>
+        </p:nvSpPr>
+        <p:spPr>
+          <a:xfrm>
+            <a:off x="1554480" y="2587752"/>
+            <a:ext cx="1188720" cy="320040"/>
+          </a:xfrm>
+          <a:prstGeom prst="rect">
+            <a:avLst/>
+          </a:prstGeom>
+          <a:noFill/>
+          <a:ln/>
+        </p:spPr>
+        <p:txBody>
+          <a:bodyPr wrap="square" lIns="0" tIns="0" rIns="0" bIns="0" rtlCol="0" anchor="t"/>
+          <a:lstStyle/>
+          <a:p>
+            <a:pPr marL="0" indent="0">
+              <a:buNone/>
+            </a:pPr>
+            <a:r>
+              <a:rPr lang="en-US" sz="1200" b="1" dirty="0">
+                <a:solidFill>
+                  <a:srgbClr val="2E3A48"/>
+                </a:solidFill>
+                <a:latin typeface="Calibri" pitchFamily="34" charset="0"/>
+                <a:ea typeface="Calibri" pitchFamily="34" charset="-122"/>
+                <a:cs typeface="Calibri" pitchFamily="34" charset="-120"/>
+              </a:rPr>
+              <a:t>in flight (GUI)</a:t>
+            </a:r>
+            <a:endParaRPr lang="en-US" sz="1200" dirty="0"/>
+          </a:p>
+        </p:txBody>
+      </p:sp>
+      <p:pic>
+        <p:nvPicPr>
+          <p:cNvPr id="7" name="Image 2" descr="C:\Users\Yitong\AppData\Local\Temp\claude\--wsl-localhost-Ubuntu-home-yitong-uav-native-ai\5626ac00-b96f-4523-b66d-3cae6d4f4d7e\scratchpad\deck\e01-zoom.png"/>
+          <p:cNvPicPr>
+            <a:picLocks noChangeAspect="1"/>
+          </p:cNvPicPr>
+          <p:nvPr/>
+        </p:nvPicPr>
+        <p:blipFill>
+          <a:blip r:embed="rId5"/>
+          <a:stretch>
+            <a:fillRect/>
+          </a:stretch>
+        </p:blipFill>
+        <p:spPr>
+          <a:xfrm>
             <a:off x="457200" y="3429000"/>
             <a:ext cx="1005840" cy="1005840"/>
           </a:xfrm>
@@ -4742,7 +4509,7 @@
           <a:bodyPr wrap="square" lIns="0" tIns="0" rIns="0" bIns="0" rtlCol="0" anchor="t"/>
           <a:lstStyle/>
           <a:p>
-            <a:pPr indent="0" marL="0">
+            <a:pPr marL="0" indent="0">
               <a:buNone/>
             </a:pPr>
             <a:r>
@@ -4786,7 +4553,7 @@
             <a:prstDash val="solid"/>
           </a:ln>
           <a:effectLst>
-            <a:outerShdw sx="100000" sy="100000" kx="0" ky="0" algn="bl" rotWithShape="0" blurRad="50800" dist="19050" dir="5400000">
+            <a:outerShdw blurRad="50800" dist="19050" dir="5400000" algn="bl" rotWithShape="0">
               <a:srgbClr val="000000">
                 <a:alpha val="12000"/>
               </a:srgbClr>
@@ -4815,7 +4582,7 @@
           <a:bodyPr wrap="square" lIns="0" tIns="0" rIns="0" bIns="0" rtlCol="0" anchor="t"/>
           <a:lstStyle/>
           <a:p>
-            <a:pPr indent="0" marL="0">
+            <a:pPr marL="0" indent="0">
               <a:buNone/>
             </a:pPr>
             <a:r>
@@ -4854,7 +4621,7 @@
           <a:bodyPr wrap="square" lIns="0" tIns="0" rIns="0" bIns="0" rtlCol="0" anchor="t"/>
           <a:lstStyle/>
           <a:p>
-            <a:pPr indent="0" marL="0">
+            <a:pPr marL="0" indent="0">
               <a:spcAft>
                 <a:spcPts val="600"/>
               </a:spcAft>
@@ -4871,12 +4638,6 @@
               </a:rPr>
               <a:t>Describe ✓ honest: </a:t>
             </a:r>
-            <a:pPr indent="0" marL="0">
-              <a:spcAft>
-                <a:spcPts val="600"/>
-              </a:spcAft>
-              <a:buNone/>
-            </a:pPr>
             <a:r>
               <a:rPr lang="en-US" sz="1400" dirty="0">
                 <a:solidFill>
@@ -4889,12 +4650,6 @@
               <a:t>"blurry blue object, white-grey oval", confidence low, needs a closer look
 </a:t>
             </a:r>
-            <a:pPr indent="0" marL="0">
-              <a:spcAft>
-                <a:spcPts val="600"/>
-              </a:spcAft>
-              <a:buNone/>
-            </a:pPr>
             <a:r>
               <a:rPr lang="en-US" sz="1400" b="1" dirty="0">
                 <a:solidFill>
@@ -4906,12 +4661,6 @@
               </a:rPr>
               <a:t>Relevance ✗ first wrong stage: </a:t>
             </a:r>
-            <a:pPr indent="0" marL="0">
-              <a:spcAft>
-                <a:spcPts val="600"/>
-              </a:spcAft>
-              <a:buNone/>
-            </a:pPr>
             <a:r>
               <a:rPr lang="en-US" sz="1400" dirty="0">
                 <a:solidFill>
@@ -4924,12 +4673,6 @@
               <a:t>picked "blue denim shorts", said low, while its rationale named the cap
 </a:t>
             </a:r>
-            <a:pPr indent="0" marL="0">
-              <a:spcAft>
-                <a:spcPts val="600"/>
-              </a:spcAft>
-              <a:buNone/>
-            </a:pPr>
             <a:r>
               <a:rPr lang="en-US" sz="1400" b="1" dirty="0">
                 <a:solidFill>
@@ -4971,7 +4714,7 @@
             <a:prstDash val="solid"/>
           </a:ln>
           <a:effectLst>
-            <a:outerShdw sx="100000" sy="100000" kx="0" ky="0" algn="bl" rotWithShape="0" blurRad="50800" dist="19050" dir="5400000">
+            <a:outerShdw blurRad="50800" dist="19050" dir="5400000" algn="bl" rotWithShape="0">
               <a:srgbClr val="000000">
                 <a:alpha val="12000"/>
               </a:srgbClr>
@@ -5000,7 +4743,7 @@
           <a:bodyPr wrap="square" lIns="0" tIns="0" rIns="0" bIns="0" rtlCol="0" anchor="t"/>
           <a:lstStyle/>
           <a:p>
-            <a:pPr indent="0" marL="0">
+            <a:pPr marL="0" indent="0">
               <a:buNone/>
             </a:pPr>
             <a:r>
@@ -5039,7 +4782,7 @@
           <a:bodyPr wrap="square" lIns="0" tIns="0" rIns="0" bIns="0" rtlCol="0" anchor="t"/>
           <a:lstStyle/>
           <a:p>
-            <a:pPr indent="0" marL="0">
+            <a:pPr marL="0" indent="0">
               <a:spcAft>
                 <a:spcPts val="600"/>
               </a:spcAft>
@@ -5056,12 +4799,6 @@
               </a:rPr>
               <a:t>Schema: </a:t>
             </a:r>
-            <a:pPr indent="0" marL="0">
-              <a:spcAft>
-                <a:spcPts val="600"/>
-              </a:spcAft>
-              <a:buNone/>
-            </a:pPr>
             <a:r>
               <a:rPr lang="en-US" sz="1400" dirty="0">
                 <a:solidFill>
@@ -5074,12 +4811,6 @@
               <a:t>possible_items before candidate_item, so it compares before it commits
 </a:t>
             </a:r>
-            <a:pPr indent="0" marL="0">
-              <a:spcAft>
-                <a:spcPts val="600"/>
-              </a:spcAft>
-              <a:buNone/>
-            </a:pPr>
             <a:r>
               <a:rPr lang="en-US" sz="1400" b="1" dirty="0">
                 <a:solidFill>
@@ -5091,12 +4822,6 @@
               </a:rPr>
               <a:t>Prompt: </a:t>
             </a:r>
-            <a:pPr indent="0" marL="0">
-              <a:spcAft>
-                <a:spcPts val="600"/>
-              </a:spcAft>
-              <a:buNone/>
-            </a:pPr>
             <a:r>
               <a:rPr lang="en-US" sz="1400" dirty="0">
                 <a:solidFill>
@@ -5109,12 +4834,6 @@
               <a:t>unclear but colour, size and outline fit → medium
 </a:t>
             </a:r>
-            <a:pPr indent="0" marL="0">
-              <a:spcAft>
-                <a:spcPts val="600"/>
-              </a:spcAft>
-              <a:buNone/>
-            </a:pPr>
             <a:r>
               <a:rPr lang="en-US" sz="1400" b="1" dirty="0">
                 <a:solidFill>
@@ -5125,24 +4844,7 @@
                 <a:cs typeface="Calibri" pitchFamily="34" charset="-120"/>
               </a:rPr>
               <a:t>→ inspect_closer → hover
-</a:t>
-            </a:r>
-            <a:pPr indent="0" marL="0">
-              <a:spcAft>
-                <a:spcPts val="600"/>
-              </a:spcAft>
-              <a:buNone/>
-            </a:pPr>
-            <a:r>
-              <a:rPr lang="en-US" sz="1400" b="1" dirty="0">
-                <a:solidFill>
-                  <a:srgbClr val="1F8A7E"/>
-                </a:solidFill>
-                <a:latin typeface="Calibri" pitchFamily="34" charset="0"/>
-                <a:ea typeface="Calibri" pitchFamily="34" charset="-122"/>
-                <a:cs typeface="Calibri" pitchFamily="34" charset="-120"/>
-              </a:rPr>
-              <a:t>→ zoomed: high → converge</a:t>
+→ zoomed: high → converge</a:t>
             </a:r>
             <a:endParaRPr lang="en-US" sz="1400" dirty="0"/>
           </a:p>
@@ -5168,7 +4870,7 @@
           </a:prstGeom>
           <a:extLst>
             <a:ext uri="{C572A759-6A51-4108-AA02-DFA0A04FC94B}">
-              <ma14:wrappingTextBoxFlag xmlns:ma14="http://schemas.microsoft.com/office/mac/drawingml/2011/main" val="0"/>
+              <ma14:wrappingTextBoxFlag xmlns:ma14="http://schemas.microsoft.com/office/mac/drawingml/2011/main" xmlns="" val="0"/>
             </a:ext>
           </a:extLst>
         </p:spPr>
@@ -5189,7 +4891,7 @@
           <a:p>
             <a:pPr algn="l"/>
             <a:fld id="{F7021451-1387-4CA6-816F-3879F97B5CBC}" type="slidenum">
-              <a:rPr b="0" lang="en-US"/>
+              <a:rPr lang="en-US" b="0"/>
               <a:t>5</a:t>
             </a:fld>
             <a:endParaRPr lang="en-US"/>
@@ -5242,11 +4944,11 @@
           <a:bodyPr wrap="square" lIns="0" tIns="0" rIns="0" bIns="0" rtlCol="0" anchor="ctr"/>
           <a:lstStyle/>
           <a:p>
-            <a:pPr indent="0" marL="0">
-              <a:buNone/>
-            </a:pPr>
-            <a:r>
-              <a:rPr lang="en-US" sz="2800" b="1" dirty="0">
+            <a:pPr marL="0" indent="0">
+              <a:buNone/>
+            </a:pPr>
+            <a:r>
+              <a:rPr lang="en-US" sz="2800" b="1" smtClean="0">
                 <a:solidFill>
                   <a:srgbClr val="FFFFFF"/>
                 </a:solidFill>
@@ -5254,7 +4956,7 @@
                 <a:ea typeface="Cambria" pitchFamily="34" charset="-122"/>
                 <a:cs typeface="Cambria" pitchFamily="34" charset="-120"/>
               </a:rPr>
-              <a:t>In flight: every clue handled, the fence held</a:t>
+              <a:t>In flight, in new-gui: the fence held</a:t>
             </a:r>
             <a:endParaRPr lang="en-US" sz="2800" dirty="0"/>
           </a:p>
@@ -5268,8 +4970,8 @@
         </p:nvSpPr>
         <p:spPr>
           <a:xfrm>
-            <a:off x="457200" y="1097280"/>
-            <a:ext cx="8229600" cy="420624"/>
+            <a:off x="5740400" y="1066800"/>
+            <a:ext cx="2946400" cy="508000"/>
           </a:xfrm>
           <a:prstGeom prst="roundRect">
             <a:avLst>
@@ -5295,8 +4997,8 @@
         </p:nvSpPr>
         <p:spPr>
           <a:xfrm>
-            <a:off x="594360" y="1216152"/>
-            <a:ext cx="182880" cy="182880"/>
+            <a:off x="5854700" y="1168400"/>
+            <a:ext cx="127000" cy="127000"/>
           </a:xfrm>
           <a:prstGeom prst="ellipse">
             <a:avLst/>
@@ -5320,8 +5022,8 @@
         </p:nvSpPr>
         <p:spPr>
           <a:xfrm>
-            <a:off x="914400" y="1188720"/>
-            <a:ext cx="2560320" cy="274320"/>
+            <a:off x="6045200" y="1079500"/>
+            <a:ext cx="2590800" cy="228600"/>
           </a:xfrm>
           <a:prstGeom prst="rect">
             <a:avLst/>
@@ -5330,14 +5032,14 @@
           <a:ln/>
         </p:spPr>
         <p:txBody>
-          <a:bodyPr wrap="square" lIns="0" tIns="0" rIns="0" bIns="0" rtlCol="0" anchor="t"/>
-          <a:lstStyle/>
-          <a:p>
-            <a:pPr indent="0" marL="0">
-              <a:buNone/>
-            </a:pPr>
-            <a:r>
-              <a:rPr lang="en-US" sz="1400" b="1" dirty="0">
+          <a:bodyPr wrap="none" lIns="0" tIns="25400" rIns="0" bIns="0" rtlCol="0" anchor="t"/>
+          <a:lstStyle/>
+          <a:p>
+            <a:pPr marL="0" indent="0">
+              <a:buNone/>
+            </a:pPr>
+            <a:r>
+              <a:rPr lang="en-US" sz="1200" b="1" smtClean="0">
                 <a:solidFill>
                   <a:srgbClr val="FFFFFF"/>
                 </a:solidFill>
@@ -5347,46 +5049,7 @@
               </a:rPr>
               <a:t>Ethan's cap</a:t>
             </a:r>
-            <a:endParaRPr lang="en-US" sz="1400" dirty="0"/>
-          </a:p>
-        </p:txBody>
-      </p:sp>
-      <p:sp>
-        <p:nvSpPr>
-          <p:cNvPr id="6" name="Text 4"/>
-          <p:cNvSpPr txBox="1"/>
-          <p:nvPr/>
-        </p:nvSpPr>
-        <p:spPr>
-          <a:xfrm>
-            <a:off x="3520440" y="1188720"/>
-            <a:ext cx="2514600" cy="274320"/>
-          </a:xfrm>
-          <a:prstGeom prst="rect">
-            <a:avLst/>
-          </a:prstGeom>
-          <a:noFill/>
-          <a:ln/>
-        </p:spPr>
-        <p:txBody>
-          <a:bodyPr wrap="square" lIns="0" tIns="0" rIns="0" bIns="0" rtlCol="0" anchor="t"/>
-          <a:lstStyle/>
-          <a:p>
-            <a:pPr indent="0" marL="0">
-              <a:buNone/>
-            </a:pPr>
-            <a:r>
-              <a:rPr lang="en-US" sz="1300" dirty="0">
-                <a:solidFill>
-                  <a:srgbClr val="C9D3DD"/>
-                </a:solidFill>
-                <a:latin typeface="Calibri" pitchFamily="34" charset="0"/>
-                <a:ea typeface="Calibri" pitchFamily="34" charset="-122"/>
-                <a:cs typeface="Calibri" pitchFamily="34" charset="-120"/>
-              </a:rPr>
-              <a:t>medium → inspect_closer</a:t>
-            </a:r>
-            <a:endParaRPr lang="en-US" sz="1300" dirty="0"/>
+            <a:endParaRPr lang="en-US" sz="1200" dirty="0"/>
           </a:p>
         </p:txBody>
       </p:sp>
@@ -5398,8 +5061,8 @@
         </p:nvSpPr>
         <p:spPr>
           <a:xfrm>
-            <a:off x="6080760" y="1188720"/>
-            <a:ext cx="2514600" cy="274320"/>
+            <a:off x="6045200" y="1308100"/>
+            <a:ext cx="2590800" cy="228600"/>
           </a:xfrm>
           <a:prstGeom prst="rect">
             <a:avLst/>
@@ -5408,16 +5071,27 @@
           <a:ln/>
         </p:spPr>
         <p:txBody>
-          <a:bodyPr wrap="square" lIns="0" tIns="0" rIns="0" bIns="0" rtlCol="0" anchor="t"/>
-          <a:lstStyle/>
-          <a:p>
-            <a:pPr indent="0" marL="0">
-              <a:buNone/>
-            </a:pPr>
-            <a:r>
-              <a:rPr lang="en-US" sz="1300" b="1" dirty="0">
-                <a:solidFill>
-                  <a:srgbClr val="3CC2B0"/>
+          <a:bodyPr wrap="none" lIns="0" tIns="12700" rIns="0" bIns="0" rtlCol="0" anchor="t"/>
+          <a:lstStyle/>
+          <a:p>
+            <a:pPr marL="0" indent="0">
+              <a:buNone/>
+            </a:pPr>
+            <a:r>
+              <a:rPr lang="en-US" sz="1050" smtClean="0">
+                <a:solidFill>
+                  <a:srgbClr val="AAB5C4"/>
+                </a:solidFill>
+                <a:latin typeface="Calibri" pitchFamily="34" charset="0"/>
+                <a:ea typeface="Calibri" pitchFamily="34" charset="-122"/>
+                <a:cs typeface="Calibri" pitchFamily="34" charset="-120"/>
+              </a:rPr>
+              <a:t>inspect_closer → </a:t>
+            </a:r>
+            <a:r>
+              <a:rPr lang="en-US" sz="1050" b="1" smtClean="0">
+                <a:solidFill>
+                  <a:srgbClr val="40C9B0"/>
                 </a:solidFill>
                 <a:latin typeface="Calibri" pitchFamily="34" charset="0"/>
                 <a:ea typeface="Calibri" pitchFamily="34" charset="-122"/>
@@ -5425,7 +5099,11 @@
               </a:rPr>
               <a:t>approved: hovered 60 s</a:t>
             </a:r>
-            <a:endParaRPr lang="en-US" sz="1300" dirty="0"/>
+            <a:endParaRPr lang="en-US" sz="1050" b="1" dirty="0">
+              <a:solidFill>
+                <a:srgbClr val="40C9B0"/>
+              </a:solidFill>
+            </a:endParaRPr>
           </a:p>
         </p:txBody>
       </p:sp>
@@ -5437,8 +5115,8 @@
         </p:nvSpPr>
         <p:spPr>
           <a:xfrm>
-            <a:off x="457200" y="1609344"/>
-            <a:ext cx="8229600" cy="420624"/>
+            <a:off x="5740400" y="1638300"/>
+            <a:ext cx="2946400" cy="508000"/>
           </a:xfrm>
           <a:prstGeom prst="roundRect">
             <a:avLst>
@@ -5464,8 +5142,8 @@
         </p:nvSpPr>
         <p:spPr>
           <a:xfrm>
-            <a:off x="594360" y="1728216"/>
-            <a:ext cx="182880" cy="182880"/>
+            <a:off x="5854700" y="1739900"/>
+            <a:ext cx="127000" cy="127000"/>
           </a:xfrm>
           <a:prstGeom prst="ellipse">
             <a:avLst/>
@@ -5489,8 +5167,8 @@
         </p:nvSpPr>
         <p:spPr>
           <a:xfrm>
-            <a:off x="914400" y="1700784"/>
-            <a:ext cx="2560320" cy="274320"/>
+            <a:off x="6045200" y="1651000"/>
+            <a:ext cx="2590800" cy="228600"/>
           </a:xfrm>
           <a:prstGeom prst="rect">
             <a:avLst/>
@@ -5499,14 +5177,14 @@
           <a:ln/>
         </p:spPr>
         <p:txBody>
-          <a:bodyPr wrap="square" lIns="0" tIns="0" rIns="0" bIns="0" rtlCol="0" anchor="t"/>
-          <a:lstStyle/>
-          <a:p>
-            <a:pPr indent="0" marL="0">
-              <a:buNone/>
-            </a:pPr>
-            <a:r>
-              <a:rPr lang="en-US" sz="1400" b="1" dirty="0">
+          <a:bodyPr wrap="none" lIns="0" tIns="25400" rIns="0" bIns="0" rtlCol="0" anchor="t"/>
+          <a:lstStyle/>
+          <a:p>
+            <a:pPr marL="0" indent="0">
+              <a:buNone/>
+            </a:pPr>
+            <a:r>
+              <a:rPr lang="en-US" sz="1200" b="1" smtClean="0">
                 <a:solidFill>
                   <a:srgbClr val="FFFFFF"/>
                 </a:solidFill>
@@ -5516,46 +5194,7 @@
               </a:rPr>
               <a:t>cap, re-reported ×2</a:t>
             </a:r>
-            <a:endParaRPr lang="en-US" sz="1400" dirty="0"/>
-          </a:p>
-        </p:txBody>
-      </p:sp>
-      <p:sp>
-        <p:nvSpPr>
-          <p:cNvPr id="11" name="Text 9"/>
-          <p:cNvSpPr txBox="1"/>
-          <p:nvPr/>
-        </p:nvSpPr>
-        <p:spPr>
-          <a:xfrm>
-            <a:off x="3520440" y="1700784"/>
-            <a:ext cx="2514600" cy="274320"/>
-          </a:xfrm>
-          <a:prstGeom prst="rect">
-            <a:avLst/>
-          </a:prstGeom>
-          <a:noFill/>
-          <a:ln/>
-        </p:spPr>
-        <p:txBody>
-          <a:bodyPr wrap="square" lIns="0" tIns="0" rIns="0" bIns="0" rtlCol="0" anchor="t"/>
-          <a:lstStyle/>
-          <a:p>
-            <a:pPr indent="0" marL="0">
-              <a:buNone/>
-            </a:pPr>
-            <a:r>
-              <a:rPr lang="en-US" sz="1300" dirty="0">
-                <a:solidFill>
-                  <a:srgbClr val="C9D3DD"/>
-                </a:solidFill>
-                <a:latin typeface="Calibri" pitchFamily="34" charset="0"/>
-                <a:ea typeface="Calibri" pitchFamily="34" charset="-122"/>
-                <a:cs typeface="Calibri" pitchFamily="34" charset="-120"/>
-              </a:rPr>
-              <a:t>medium → inspect_closer</a:t>
-            </a:r>
-            <a:endParaRPr lang="en-US" sz="1300" dirty="0"/>
+            <a:endParaRPr lang="en-US" sz="1200" dirty="0"/>
           </a:p>
         </p:txBody>
       </p:sp>
@@ -5567,8 +5206,8 @@
         </p:nvSpPr>
         <p:spPr>
           <a:xfrm>
-            <a:off x="6080760" y="1700784"/>
-            <a:ext cx="2514600" cy="274320"/>
+            <a:off x="6045200" y="1879600"/>
+            <a:ext cx="2590800" cy="228600"/>
           </a:xfrm>
           <a:prstGeom prst="rect">
             <a:avLst/>
@@ -5577,16 +5216,27 @@
           <a:ln/>
         </p:spPr>
         <p:txBody>
-          <a:bodyPr wrap="square" lIns="0" tIns="0" rIns="0" bIns="0" rtlCol="0" anchor="t"/>
-          <a:lstStyle/>
-          <a:p>
-            <a:pPr indent="0" marL="0">
-              <a:buNone/>
-            </a:pPr>
-            <a:r>
-              <a:rPr lang="en-US" sz="1300" b="1" dirty="0">
-                <a:solidFill>
-                  <a:srgbClr val="FF7A6B"/>
+          <a:bodyPr wrap="none" lIns="0" tIns="12700" rIns="0" bIns="0" rtlCol="0" anchor="t"/>
+          <a:lstStyle/>
+          <a:p>
+            <a:pPr marL="0" indent="0">
+              <a:buNone/>
+            </a:pPr>
+            <a:r>
+              <a:rPr lang="en-US" sz="1050" smtClean="0">
+                <a:solidFill>
+                  <a:srgbClr val="AAB5C4"/>
+                </a:solidFill>
+                <a:latin typeface="Calibri" pitchFamily="34" charset="0"/>
+                <a:ea typeface="Calibri" pitchFamily="34" charset="-122"/>
+                <a:cs typeface="Calibri" pitchFamily="34" charset="-120"/>
+              </a:rPr>
+              <a:t>inspect_closer → </a:t>
+            </a:r>
+            <a:r>
+              <a:rPr lang="en-US" sz="1050" b="1" smtClean="0">
+                <a:solidFill>
+                  <a:srgbClr val="FA8072"/>
                 </a:solidFill>
                 <a:latin typeface="Calibri" pitchFamily="34" charset="0"/>
                 <a:ea typeface="Calibri" pitchFamily="34" charset="-122"/>
@@ -5594,7 +5244,11 @@
               </a:rPr>
               <a:t>rejected: busy, same spot</a:t>
             </a:r>
-            <a:endParaRPr lang="en-US" sz="1300" dirty="0"/>
+            <a:endParaRPr lang="en-US" sz="1050" b="1" dirty="0">
+              <a:solidFill>
+                <a:srgbClr val="FA8072"/>
+              </a:solidFill>
+            </a:endParaRPr>
           </a:p>
         </p:txBody>
       </p:sp>
@@ -5606,8 +5260,8 @@
         </p:nvSpPr>
         <p:spPr>
           <a:xfrm>
-            <a:off x="457200" y="2121408"/>
-            <a:ext cx="8229600" cy="420624"/>
+            <a:off x="5740400" y="2209800"/>
+            <a:ext cx="2946400" cy="508000"/>
           </a:xfrm>
           <a:prstGeom prst="roundRect">
             <a:avLst>
@@ -5633,8 +5287,8 @@
         </p:nvSpPr>
         <p:spPr>
           <a:xfrm>
-            <a:off x="594360" y="2240280"/>
-            <a:ext cx="182880" cy="182880"/>
+            <a:off x="5854700" y="2311400"/>
+            <a:ext cx="127000" cy="127000"/>
           </a:xfrm>
           <a:prstGeom prst="ellipse">
             <a:avLst/>
@@ -5658,8 +5312,8 @@
         </p:nvSpPr>
         <p:spPr>
           <a:xfrm>
-            <a:off x="914400" y="2212848"/>
-            <a:ext cx="2560320" cy="274320"/>
+            <a:off x="6045200" y="2222500"/>
+            <a:ext cx="2590800" cy="228600"/>
           </a:xfrm>
           <a:prstGeom prst="rect">
             <a:avLst/>
@@ -5668,14 +5322,14 @@
           <a:ln/>
         </p:spPr>
         <p:txBody>
-          <a:bodyPr wrap="square" lIns="0" tIns="0" rIns="0" bIns="0" rtlCol="0" anchor="t"/>
-          <a:lstStyle/>
-          <a:p>
-            <a:pPr indent="0" marL="0">
-              <a:buNone/>
-            </a:pPr>
-            <a:r>
-              <a:rPr lang="en-US" sz="1400" b="1" dirty="0">
+          <a:bodyPr wrap="none" lIns="0" tIns="25400" rIns="0" bIns="0" rtlCol="0" anchor="t"/>
+          <a:lstStyle/>
+          <a:p>
+            <a:pPr marL="0" indent="0">
+              <a:buNone/>
+            </a:pPr>
+            <a:r>
+              <a:rPr lang="en-US" sz="1200" b="1" smtClean="0">
                 <a:solidFill>
                   <a:srgbClr val="FFFFFF"/>
                 </a:solidFill>
@@ -5685,46 +5339,7 @@
               </a:rPr>
               <a:t>Ethan's backpack</a:t>
             </a:r>
-            <a:endParaRPr lang="en-US" sz="1400" dirty="0"/>
-          </a:p>
-        </p:txBody>
-      </p:sp>
-      <p:sp>
-        <p:nvSpPr>
-          <p:cNvPr id="16" name="Text 14"/>
-          <p:cNvSpPr txBox="1"/>
-          <p:nvPr/>
-        </p:nvSpPr>
-        <p:spPr>
-          <a:xfrm>
-            <a:off x="3520440" y="2212848"/>
-            <a:ext cx="2514600" cy="274320"/>
-          </a:xfrm>
-          <a:prstGeom prst="rect">
-            <a:avLst/>
-          </a:prstGeom>
-          <a:noFill/>
-          <a:ln/>
-        </p:spPr>
-        <p:txBody>
-          <a:bodyPr wrap="square" lIns="0" tIns="0" rIns="0" bIns="0" rtlCol="0" anchor="t"/>
-          <a:lstStyle/>
-          <a:p>
-            <a:pPr indent="0" marL="0">
-              <a:buNone/>
-            </a:pPr>
-            <a:r>
-              <a:rPr lang="en-US" sz="1300" dirty="0">
-                <a:solidFill>
-                  <a:srgbClr val="C9D3DD"/>
-                </a:solidFill>
-                <a:latin typeface="Calibri" pitchFamily="34" charset="0"/>
-                <a:ea typeface="Calibri" pitchFamily="34" charset="-122"/>
-                <a:cs typeface="Calibri" pitchFamily="34" charset="-120"/>
-              </a:rPr>
-              <a:t>medium → inspect_closer</a:t>
-            </a:r>
-            <a:endParaRPr lang="en-US" sz="1300" dirty="0"/>
+            <a:endParaRPr lang="en-US" sz="1200" dirty="0"/>
           </a:p>
         </p:txBody>
       </p:sp>
@@ -5736,8 +5351,8 @@
         </p:nvSpPr>
         <p:spPr>
           <a:xfrm>
-            <a:off x="6080760" y="2212848"/>
-            <a:ext cx="2514600" cy="274320"/>
+            <a:off x="6045200" y="2451100"/>
+            <a:ext cx="2590800" cy="228600"/>
           </a:xfrm>
           <a:prstGeom prst="rect">
             <a:avLst/>
@@ -5746,16 +5361,27 @@
           <a:ln/>
         </p:spPr>
         <p:txBody>
-          <a:bodyPr wrap="square" lIns="0" tIns="0" rIns="0" bIns="0" rtlCol="0" anchor="t"/>
-          <a:lstStyle/>
-          <a:p>
-            <a:pPr indent="0" marL="0">
-              <a:buNone/>
-            </a:pPr>
-            <a:r>
-              <a:rPr lang="en-US" sz="1300" b="1" dirty="0">
-                <a:solidFill>
-                  <a:srgbClr val="3CC2B0"/>
+          <a:bodyPr wrap="none" lIns="0" tIns="12700" rIns="0" bIns="0" rtlCol="0" anchor="t"/>
+          <a:lstStyle/>
+          <a:p>
+            <a:pPr marL="0" indent="0">
+              <a:buNone/>
+            </a:pPr>
+            <a:r>
+              <a:rPr lang="en-US" sz="1050" smtClean="0">
+                <a:solidFill>
+                  <a:srgbClr val="AAB5C4"/>
+                </a:solidFill>
+                <a:latin typeface="Calibri" pitchFamily="34" charset="0"/>
+                <a:ea typeface="Calibri" pitchFamily="34" charset="-122"/>
+                <a:cs typeface="Calibri" pitchFamily="34" charset="-120"/>
+              </a:rPr>
+              <a:t>inspect_closer → </a:t>
+            </a:r>
+            <a:r>
+              <a:rPr lang="en-US" sz="1050" b="1" smtClean="0">
+                <a:solidFill>
+                  <a:srgbClr val="40C9B0"/>
                 </a:solidFill>
                 <a:latin typeface="Calibri" pitchFamily="34" charset="0"/>
                 <a:ea typeface="Calibri" pitchFamily="34" charset="-122"/>
@@ -5763,7 +5389,11 @@
               </a:rPr>
               <a:t>approved: hovered 60 s</a:t>
             </a:r>
-            <a:endParaRPr lang="en-US" sz="1300" dirty="0"/>
+            <a:endParaRPr lang="en-US" sz="1050" b="1" dirty="0">
+              <a:solidFill>
+                <a:srgbClr val="40C9B0"/>
+              </a:solidFill>
+            </a:endParaRPr>
           </a:p>
         </p:txBody>
       </p:sp>
@@ -5775,8 +5405,8 @@
         </p:nvSpPr>
         <p:spPr>
           <a:xfrm>
-            <a:off x="457200" y="2633472"/>
-            <a:ext cx="8229600" cy="420624"/>
+            <a:off x="5740400" y="2781300"/>
+            <a:ext cx="2946400" cy="508000"/>
           </a:xfrm>
           <a:prstGeom prst="roundRect">
             <a:avLst>
@@ -5802,8 +5432,8 @@
         </p:nvSpPr>
         <p:spPr>
           <a:xfrm>
-            <a:off x="594360" y="2752344"/>
-            <a:ext cx="182880" cy="182880"/>
+            <a:off x="5854700" y="2882900"/>
+            <a:ext cx="127000" cy="127000"/>
           </a:xfrm>
           <a:prstGeom prst="ellipse">
             <a:avLst/>
@@ -5827,8 +5457,8 @@
         </p:nvSpPr>
         <p:spPr>
           <a:xfrm>
-            <a:off x="914400" y="2724912"/>
-            <a:ext cx="2560320" cy="274320"/>
+            <a:off x="6045200" y="2794000"/>
+            <a:ext cx="2590800" cy="228600"/>
           </a:xfrm>
           <a:prstGeom prst="rect">
             <a:avLst/>
@@ -5837,14 +5467,14 @@
           <a:ln/>
         </p:spPr>
         <p:txBody>
-          <a:bodyPr wrap="square" lIns="0" tIns="0" rIns="0" bIns="0" rtlCol="0" anchor="t"/>
-          <a:lstStyle/>
-          <a:p>
-            <a:pPr indent="0" marL="0">
-              <a:buNone/>
-            </a:pPr>
-            <a:r>
-              <a:rPr lang="en-US" sz="1400" b="1" dirty="0">
+          <a:bodyPr wrap="none" lIns="0" tIns="25400" rIns="0" bIns="0" rtlCol="0" anchor="t"/>
+          <a:lstStyle/>
+          <a:p>
+            <a:pPr marL="0" indent="0">
+              <a:buNone/>
+            </a:pPr>
+            <a:r>
+              <a:rPr lang="en-US" sz="1200" b="1" smtClean="0">
                 <a:solidFill>
                   <a:srgbClr val="FFFFFF"/>
                 </a:solidFill>
@@ -5854,46 +5484,7 @@
               </a:rPr>
               <a:t>beanie, ball, shoe, doll</a:t>
             </a:r>
-            <a:endParaRPr lang="en-US" sz="1400" dirty="0"/>
-          </a:p>
-        </p:txBody>
-      </p:sp>
-      <p:sp>
-        <p:nvSpPr>
-          <p:cNvPr id="21" name="Text 19"/>
-          <p:cNvSpPr txBox="1"/>
-          <p:nvPr/>
-        </p:nvSpPr>
-        <p:spPr>
-          <a:xfrm>
-            <a:off x="3520440" y="2724912"/>
-            <a:ext cx="2514600" cy="274320"/>
-          </a:xfrm>
-          <a:prstGeom prst="rect">
-            <a:avLst/>
-          </a:prstGeom>
-          <a:noFill/>
-          <a:ln/>
-        </p:spPr>
-        <p:txBody>
-          <a:bodyPr wrap="square" lIns="0" tIns="0" rIns="0" bIns="0" rtlCol="0" anchor="t"/>
-          <a:lstStyle/>
-          <a:p>
-            <a:pPr indent="0" marL="0">
-              <a:buNone/>
-            </a:pPr>
-            <a:r>
-              <a:rPr lang="en-US" sz="1300" dirty="0">
-                <a:solidFill>
-                  <a:srgbClr val="C9D3DD"/>
-                </a:solidFill>
-                <a:latin typeface="Calibri" pitchFamily="34" charset="0"/>
-                <a:ea typeface="Calibri" pitchFamily="34" charset="-122"/>
-                <a:cs typeface="Calibri" pitchFamily="34" charset="-120"/>
-              </a:rPr>
-              <a:t>low / none → log / ignore</a:t>
-            </a:r>
-            <a:endParaRPr lang="en-US" sz="1300" dirty="0"/>
+            <a:endParaRPr lang="en-US" sz="1200" dirty="0"/>
           </a:p>
         </p:txBody>
       </p:sp>
@@ -5905,8 +5496,8 @@
         </p:nvSpPr>
         <p:spPr>
           <a:xfrm>
-            <a:off x="6080760" y="2724912"/>
-            <a:ext cx="2514600" cy="274320"/>
+            <a:off x="6045200" y="3022600"/>
+            <a:ext cx="2590800" cy="228600"/>
           </a:xfrm>
           <a:prstGeom prst="rect">
             <a:avLst/>
@@ -5915,16 +5506,27 @@
           <a:ln/>
         </p:spPr>
         <p:txBody>
-          <a:bodyPr wrap="square" lIns="0" tIns="0" rIns="0" bIns="0" rtlCol="0" anchor="t"/>
-          <a:lstStyle/>
-          <a:p>
-            <a:pPr indent="0" marL="0">
-              <a:buNone/>
-            </a:pPr>
-            <a:r>
-              <a:rPr lang="en-US" sz="1300" b="1" dirty="0">
-                <a:solidFill>
-                  <a:srgbClr val="A9B6C3"/>
+          <a:bodyPr wrap="none" lIns="0" tIns="12700" rIns="0" bIns="0" rtlCol="0" anchor="t"/>
+          <a:lstStyle/>
+          <a:p>
+            <a:pPr marL="0" indent="0">
+              <a:buNone/>
+            </a:pPr>
+            <a:r>
+              <a:rPr lang="en-US" sz="1050" smtClean="0">
+                <a:solidFill>
+                  <a:srgbClr val="AAB5C4"/>
+                </a:solidFill>
+                <a:latin typeface="Calibri" pitchFamily="34" charset="0"/>
+                <a:ea typeface="Calibri" pitchFamily="34" charset="-122"/>
+                <a:cs typeface="Calibri" pitchFamily="34" charset="-120"/>
+              </a:rPr>
+              <a:t>log / ignore → </a:t>
+            </a:r>
+            <a:r>
+              <a:rPr lang="en-US" sz="1050" b="1" smtClean="0">
+                <a:solidFill>
+                  <a:srgbClr val="AAB5C4"/>
                 </a:solidFill>
                 <a:latin typeface="Calibri" pitchFamily="34" charset="0"/>
                 <a:ea typeface="Calibri" pitchFamily="34" charset="-122"/>
@@ -5932,7 +5534,11 @@
               </a:rPr>
               <a:t>nothing flew</a:t>
             </a:r>
-            <a:endParaRPr lang="en-US" sz="1300" dirty="0"/>
+            <a:endParaRPr lang="en-US" sz="1050" b="1" dirty="0">
+              <a:solidFill>
+                <a:srgbClr val="AAB5C4"/>
+              </a:solidFill>
+            </a:endParaRPr>
           </a:p>
         </p:txBody>
       </p:sp>
@@ -5944,8 +5550,8 @@
         </p:nvSpPr>
         <p:spPr>
           <a:xfrm>
-            <a:off x="457200" y="3145536"/>
-            <a:ext cx="8229600" cy="420624"/>
+            <a:off x="5740400" y="3352800"/>
+            <a:ext cx="2946400" cy="508000"/>
           </a:xfrm>
           <a:prstGeom prst="roundRect">
             <a:avLst>
@@ -5971,8 +5577,8 @@
         </p:nvSpPr>
         <p:spPr>
           <a:xfrm>
-            <a:off x="594360" y="3264408"/>
-            <a:ext cx="182880" cy="182880"/>
+            <a:off x="5854700" y="3454400"/>
+            <a:ext cx="127000" cy="127000"/>
           </a:xfrm>
           <a:prstGeom prst="ellipse">
             <a:avLst/>
@@ -5996,8 +5602,8 @@
         </p:nvSpPr>
         <p:spPr>
           <a:xfrm>
-            <a:off x="914400" y="3236976"/>
-            <a:ext cx="2560320" cy="274320"/>
+            <a:off x="6045200" y="3365500"/>
+            <a:ext cx="2590800" cy="228600"/>
           </a:xfrm>
           <a:prstGeom prst="rect">
             <a:avLst/>
@@ -6006,14 +5612,14 @@
           <a:ln/>
         </p:spPr>
         <p:txBody>
-          <a:bodyPr wrap="square" lIns="0" tIns="0" rIns="0" bIns="0" rtlCol="0" anchor="t"/>
-          <a:lstStyle/>
-          <a:p>
-            <a:pPr indent="0" marL="0">
-              <a:buNone/>
-            </a:pPr>
-            <a:r>
-              <a:rPr lang="en-US" sz="1400" b="1" dirty="0">
+          <a:bodyPr wrap="none" lIns="0" tIns="25400" rIns="0" bIns="0" rtlCol="0" anchor="t"/>
+          <a:lstStyle/>
+          <a:p>
+            <a:pPr marL="0" indent="0">
+              <a:buNone/>
+            </a:pPr>
+            <a:r>
+              <a:rPr lang="en-US" sz="1200" b="1" smtClean="0">
                 <a:solidFill>
                   <a:srgbClr val="FFFFFF"/>
                 </a:solidFill>
@@ -6021,48 +5627,9 @@
                 <a:ea typeface="Calibri" pitchFamily="34" charset="-122"/>
                 <a:cs typeface="Calibri" pitchFamily="34" charset="-120"/>
               </a:rPr>
-              <a:t>2 converges at 26% battery</a:t>
-            </a:r>
-            <a:endParaRPr lang="en-US" sz="1400" dirty="0"/>
-          </a:p>
-        </p:txBody>
-      </p:sp>
-      <p:sp>
-        <p:nvSpPr>
-          <p:cNvPr id="26" name="Text 24"/>
-          <p:cNvSpPr txBox="1"/>
-          <p:nvPr/>
-        </p:nvSpPr>
-        <p:spPr>
-          <a:xfrm>
-            <a:off x="3520440" y="3236976"/>
-            <a:ext cx="2514600" cy="274320"/>
-          </a:xfrm>
-          <a:prstGeom prst="rect">
-            <a:avLst/>
-          </a:prstGeom>
-          <a:noFill/>
-          <a:ln/>
-        </p:spPr>
-        <p:txBody>
-          <a:bodyPr wrap="square" lIns="0" tIns="0" rIns="0" bIns="0" rtlCol="0" anchor="t"/>
-          <a:lstStyle/>
-          <a:p>
-            <a:pPr indent="0" marL="0">
-              <a:buNone/>
-            </a:pPr>
-            <a:r>
-              <a:rPr lang="en-US" sz="1300" dirty="0">
-                <a:solidFill>
-                  <a:srgbClr val="C9D3DD"/>
-                </a:solidFill>
-                <a:latin typeface="Calibri" pitchFamily="34" charset="0"/>
-                <a:ea typeface="Calibri" pitchFamily="34" charset="-122"/>
-                <a:cs typeface="Calibri" pitchFamily="34" charset="-120"/>
-              </a:rPr>
-              <a:t>(inject_clue.py)</a:t>
-            </a:r>
-            <a:endParaRPr lang="en-US" sz="1300" dirty="0"/>
+              <a:t>2 converges at 26%</a:t>
+            </a:r>
+            <a:endParaRPr lang="en-US" sz="1200" dirty="0"/>
           </a:p>
         </p:txBody>
       </p:sp>
@@ -6074,8 +5641,8 @@
         </p:nvSpPr>
         <p:spPr>
           <a:xfrm>
-            <a:off x="6080760" y="3236976"/>
-            <a:ext cx="2514600" cy="274320"/>
+            <a:off x="6045200" y="3594100"/>
+            <a:ext cx="2590800" cy="228600"/>
           </a:xfrm>
           <a:prstGeom prst="rect">
             <a:avLst/>
@@ -6084,16 +5651,27 @@
           <a:ln/>
         </p:spPr>
         <p:txBody>
-          <a:bodyPr wrap="square" lIns="0" tIns="0" rIns="0" bIns="0" rtlCol="0" anchor="t"/>
-          <a:lstStyle/>
-          <a:p>
-            <a:pPr indent="0" marL="0">
-              <a:buNone/>
-            </a:pPr>
-            <a:r>
-              <a:rPr lang="en-US" sz="1300" b="1" dirty="0">
-                <a:solidFill>
-                  <a:srgbClr val="FF7A6B"/>
+          <a:bodyPr wrap="none" lIns="0" tIns="12700" rIns="0" bIns="0" rtlCol="0" anchor="t"/>
+          <a:lstStyle/>
+          <a:p>
+            <a:pPr marL="0" indent="0">
+              <a:buNone/>
+            </a:pPr>
+            <a:r>
+              <a:rPr lang="en-US" sz="1050" smtClean="0">
+                <a:solidFill>
+                  <a:srgbClr val="AAB5C4"/>
+                </a:solidFill>
+                <a:latin typeface="Calibri" pitchFamily="34" charset="0"/>
+                <a:ea typeface="Calibri" pitchFamily="34" charset="-122"/>
+                <a:cs typeface="Calibri" pitchFamily="34" charset="-120"/>
+              </a:rPr>
+              <a:t>inject_clue.py → </a:t>
+            </a:r>
+            <a:r>
+              <a:rPr lang="en-US" sz="1050" b="1" smtClean="0">
+                <a:solidFill>
+                  <a:srgbClr val="FA8072"/>
                 </a:solidFill>
                 <a:latin typeface="Calibri" pitchFamily="34" charset="0"/>
                 <a:ea typeface="Calibri" pitchFamily="34" charset="-122"/>
@@ -6101,7 +5679,11 @@
               </a:rPr>
               <a:t>rejected: reserve</a:t>
             </a:r>
-            <a:endParaRPr lang="en-US" sz="1300" dirty="0"/>
+            <a:endParaRPr lang="en-US" sz="1050" b="1" dirty="0">
+              <a:solidFill>
+                <a:srgbClr val="FA8072"/>
+              </a:solidFill>
+            </a:endParaRPr>
           </a:p>
         </p:txBody>
       </p:sp>
@@ -6113,8 +5695,8 @@
         </p:nvSpPr>
         <p:spPr>
           <a:xfrm>
-            <a:off x="457200" y="3794760"/>
-            <a:ext cx="8229600" cy="731520"/>
+            <a:off x="457200" y="4394200"/>
+            <a:ext cx="8229600" cy="304800"/>
           </a:xfrm>
           <a:prstGeom prst="rect">
             <a:avLst/>
@@ -6126,13 +5708,13 @@
           <a:bodyPr wrap="square" lIns="0" tIns="0" rIns="0" bIns="0" rtlCol="0" anchor="t"/>
           <a:lstStyle/>
           <a:p>
-            <a:pPr indent="0" marL="0">
-              <a:buNone/>
-            </a:pPr>
-            <a:r>
-              <a:rPr lang="en-US" sz="1500" b="1" dirty="0">
-                <a:solidFill>
-                  <a:srgbClr val="F26B1D"/>
+            <a:pPr marL="0" indent="0">
+              <a:buNone/>
+            </a:pPr>
+            <a:r>
+              <a:rPr lang="en-US" sz="1400" b="1" smtClean="0">
+                <a:solidFill>
+                  <a:srgbClr val="F26A21"/>
                 </a:solidFill>
                 <a:latin typeface="Calibri" pitchFamily="34" charset="0"/>
                 <a:ea typeface="Calibri" pitchFamily="34" charset="-122"/>
@@ -6140,11 +5722,8 @@
               </a:rPr>
               <a:t>Never left to the model: </a:t>
             </a:r>
-            <a:pPr indent="0" marL="0">
-              <a:buNone/>
-            </a:pPr>
-            <a:r>
-              <a:rPr lang="en-US" sz="1500" dirty="0">
+            <a:r>
+              <a:rPr lang="en-US" sz="1400" smtClean="0">
                 <a:solidFill>
                   <a:srgbClr val="FFFFFF"/>
                 </a:solidFill>
@@ -6154,44 +5733,17 @@
               </a:rPr>
               <a:t>coordinates, feasibility, a second look, a delivery.</a:t>
             </a:r>
-            <a:endParaRPr lang="en-US" sz="1500" dirty="0"/>
-          </a:p>
-          <a:p>
-            <a:pPr indent="0" marL="0">
-              <a:buNone/>
-            </a:pPr>
-            <a:r>
-              <a:rPr lang="en-US" sz="1500" dirty="0">
-                <a:solidFill>
-                  <a:srgbClr val="C9D3DD"/>
-                </a:solidFill>
-                <a:latin typeface="Calibri" pitchFamily="34" charset="0"/>
-                <a:ea typeface="Calibri" pitchFamily="34" charset="-122"/>
-                <a:cs typeface="Calibri" pitchFamily="34" charset="-120"/>
-              </a:rPr>
-              <a:t>One command runs it all: </a:t>
-            </a:r>
-            <a:pPr indent="0" marL="0">
-              <a:buNone/>
-            </a:pPr>
-            <a:r>
-              <a:rPr lang="en-US" sz="1500" b="1" dirty="0">
-                <a:solidFill>
-                  <a:srgbClr val="FFFFFF"/>
-                </a:solidFill>
-                <a:latin typeface="Calibri" pitchFamily="34" charset="0"/>
-                <a:ea typeface="Calibri" pitchFamily="34" charset="-122"/>
-                <a:cs typeface="Calibri" pitchFamily="34" charset="-120"/>
-              </a:rPr>
-              <a:t>bash hw07/run_demo.sh</a:t>
-            </a:r>
-            <a:endParaRPr lang="en-US" sz="1500" dirty="0"/>
-          </a:p>
-        </p:txBody>
-      </p:sp>
-      <p:sp>
-        <p:nvSpPr>
-          <p:cNvPr id="25" name="Slide Number Placeholder 0"/>
+            <a:endParaRPr lang="en-US" sz="1400" dirty="0">
+              <a:solidFill>
+                <a:srgbClr val="FFFFFF"/>
+              </a:solidFill>
+            </a:endParaRPr>
+          </a:p>
+        </p:txBody>
+      </p:sp>
+      <p:sp>
+        <p:nvSpPr>
+          <p:cNvPr id="29" name="Slide Number Placeholder 0"/>
           <p:cNvSpPr>
             <a:spLocks noGrp="1"/>
           </p:cNvSpPr>
@@ -6209,7 +5761,7 @@
           </a:prstGeom>
           <a:extLst>
             <a:ext uri="{C572A759-6A51-4108-AA02-DFA0A04FC94B}">
-              <ma14:wrappingTextBoxFlag xmlns:ma14="http://schemas.microsoft.com/office/mac/drawingml/2011/main" val="0"/>
+              <ma14:wrappingTextBoxFlag xmlns:ma14="http://schemas.microsoft.com/office/mac/drawingml/2011/main" xmlns="" val="0"/>
             </a:ext>
           </a:extLst>
         </p:spPr>
@@ -6230,10 +5782,201 @@
           <a:p>
             <a:pPr algn="l"/>
             <a:fld id="{F7021451-1387-4CA6-816F-3879F97B5CBC}" type="slidenum">
-              <a:rPr b="0" lang="en-US"/>
+              <a:rPr lang="en-US" b="0"/>
               <a:t>6</a:t>
             </a:fld>
             <a:endParaRPr lang="en-US"/>
+          </a:p>
+        </p:txBody>
+      </p:sp>
+      <p:pic>
+        <p:nvPicPr>
+          <p:cNvPr id="30" name="GUI screenshot"/>
+          <p:cNvPicPr>
+            <a:picLocks/>
+          </p:cNvPicPr>
+          <p:nvPr/>
+        </p:nvPicPr>
+        <p:blipFill>
+          <a:blip r:embed="rId3">
+            <a:extLst>
+              <a:ext uri="{28A0092B-C50C-407E-A947-70E740481C1C}">
+                <a14:useLocalDpi xmlns:a14="http://schemas.microsoft.com/office/drawing/2010/main" val="0"/>
+              </a:ext>
+            </a:extLst>
+          </a:blip>
+          <a:stretch>
+            <a:fillRect/>
+          </a:stretch>
+        </p:blipFill>
+        <p:spPr>
+          <a:xfrm>
+            <a:off x="457200" y="1066800"/>
+            <a:ext cx="5130800" cy="2900348"/>
+          </a:xfrm>
+          <a:prstGeom prst="rect">
+            <a:avLst/>
+          </a:prstGeom>
+          <a:ln w="9525">
+            <a:solidFill>
+              <a:srgbClr val="465263"/>
+            </a:solidFill>
+          </a:ln>
+        </p:spPr>
+      </p:pic>
+      <p:sp>
+        <p:nvSpPr>
+          <p:cNvPr id="31" name="camera outline"/>
+          <p:cNvSpPr/>
+          <p:nvPr/>
+        </p:nvSpPr>
+        <p:spPr>
+          <a:xfrm>
+            <a:off x="3407029" y="1097250"/>
+            <a:ext cx="1256057" cy="1092388"/>
+          </a:xfrm>
+          <a:prstGeom prst="roundRect">
+            <a:avLst/>
+          </a:prstGeom>
+          <a:noFill/>
+          <a:ln w="25400" cap="flat" cmpd="sng" algn="ctr">
+            <a:solidFill>
+              <a:srgbClr val="F26A21"/>
+            </a:solidFill>
+            <a:prstDash val="solid"/>
+            <a:miter lim="800000"/>
+          </a:ln>
+          <a:effectLst/>
+          <a:extLst>
+            <a:ext uri="{909E8E84-426E-40DD-AFC4-6F175D3DCCD1}">
+              <a14:hiddenFill xmlns:a14="http://schemas.microsoft.com/office/drawing/2010/main">
+                <a:solidFill>
+                  <a:schemeClr val="accent1"/>
+                </a:solidFill>
+              </a14:hiddenFill>
+            </a:ext>
+          </a:extLst>
+        </p:spPr>
+        <p:style>
+          <a:lnRef idx="2">
+            <a:schemeClr val="accent1">
+              <a:shade val="50000"/>
+            </a:schemeClr>
+          </a:lnRef>
+          <a:fillRef idx="1">
+            <a:schemeClr val="accent1"/>
+          </a:fillRef>
+          <a:effectRef idx="0">
+            <a:schemeClr val="accent1"/>
+          </a:effectRef>
+          <a:fontRef idx="minor">
+            <a:schemeClr val="lt1"/>
+          </a:fontRef>
+        </p:style>
+        <p:txBody>
+          <a:bodyPr rtlCol="0" anchor="ctr"/>
+          <a:lstStyle/>
+          <a:p>
+            <a:pPr algn="ctr"/>
+            <a:endParaRPr lang="en-US"/>
+          </a:p>
+        </p:txBody>
+      </p:sp>
+      <p:sp>
+        <p:nvSpPr>
+          <p:cNvPr id="32" name="drone circle"/>
+          <p:cNvSpPr/>
+          <p:nvPr/>
+        </p:nvSpPr>
+        <p:spPr>
+          <a:xfrm>
+            <a:off x="896047" y="3305995"/>
+            <a:ext cx="279400" cy="279400"/>
+          </a:xfrm>
+          <a:prstGeom prst="ellipse">
+            <a:avLst/>
+          </a:prstGeom>
+          <a:noFill/>
+          <a:ln w="25400" cap="flat" cmpd="sng" algn="ctr">
+            <a:solidFill>
+              <a:srgbClr val="F26A21"/>
+            </a:solidFill>
+            <a:prstDash val="solid"/>
+            <a:miter lim="800000"/>
+          </a:ln>
+          <a:effectLst/>
+          <a:extLst>
+            <a:ext uri="{909E8E84-426E-40DD-AFC4-6F175D3DCCD1}">
+              <a14:hiddenFill xmlns:a14="http://schemas.microsoft.com/office/drawing/2010/main">
+                <a:solidFill>
+                  <a:schemeClr val="accent1"/>
+                </a:solidFill>
+              </a14:hiddenFill>
+            </a:ext>
+          </a:extLst>
+        </p:spPr>
+        <p:style>
+          <a:lnRef idx="2">
+            <a:schemeClr val="accent1">
+              <a:shade val="50000"/>
+            </a:schemeClr>
+          </a:lnRef>
+          <a:fillRef idx="1">
+            <a:schemeClr val="accent1"/>
+          </a:fillRef>
+          <a:effectRef idx="0">
+            <a:schemeClr val="accent1"/>
+          </a:effectRef>
+          <a:fontRef idx="minor">
+            <a:schemeClr val="lt1"/>
+          </a:fontRef>
+        </p:style>
+        <p:txBody>
+          <a:bodyPr rtlCol="0" anchor="ctr"/>
+          <a:lstStyle/>
+          <a:p>
+            <a:pPr algn="ctr"/>
+            <a:endParaRPr lang="en-US"/>
+          </a:p>
+        </p:txBody>
+      </p:sp>
+      <p:sp>
+        <p:nvSpPr>
+          <p:cNvPr id="33" name="caption"/>
+          <p:cNvSpPr txBox="1"/>
+          <p:nvPr/>
+        </p:nvSpPr>
+        <p:spPr>
+          <a:xfrm>
+            <a:off x="457200" y="4005249"/>
+            <a:ext cx="5130800" cy="364202"/>
+          </a:xfrm>
+          <a:prstGeom prst="rect">
+            <a:avLst/>
+          </a:prstGeom>
+          <a:noFill/>
+        </p:spPr>
+        <p:txBody>
+          <a:bodyPr vert="horz" lIns="0" tIns="25400" rtlCol="0">
+            <a:spAutoFit/>
+          </a:bodyPr>
+          <a:lstStyle/>
+          <a:p>
+            <a:r>
+              <a:rPr lang="en-US" sz="950" smtClean="0">
+                <a:solidFill>
+                  <a:srgbClr val="AAB5C4"/>
+                </a:solidFill>
+                <a:latin typeface="Calibri" panose="020F0502020204030204" pitchFamily="34" charset="0"/>
+              </a:rPr>
+              <a:t>Live, 15 Oct: Fuchsia (circled) hovers over Ethan's cap after the AI's inspect_closer was approved; its camera (boxed) shows the cap. bash hw07/run_demo.sh</a:t>
+            </a:r>
+            <a:endParaRPr lang="en-US" sz="950">
+              <a:solidFill>
+                <a:srgbClr val="AAB5C4"/>
+              </a:solidFill>
+              <a:latin typeface="Calibri" panose="020F0502020204030204" pitchFamily="34" charset="0"/>
+            </a:endParaRPr>
           </a:p>
         </p:txBody>
       </p:sp>
@@ -6538,4 +6281,265 @@
     </a:ext>
   </a:extLst>
 </a:theme>
+</file>
+
+<file path=ppt/theme/theme2.xml><?xml version="1.0" encoding="utf-8"?>
+<a:theme xmlns:a="http://schemas.openxmlformats.org/drawingml/2006/main" name="Office Theme">
+  <a:themeElements>
+    <a:clrScheme name="Office">
+      <a:dk1>
+        <a:sysClr val="windowText" lastClr="000000"/>
+      </a:dk1>
+      <a:lt1>
+        <a:sysClr val="window" lastClr="FFFFFF"/>
+      </a:lt1>
+      <a:dk2>
+        <a:srgbClr val="44546A"/>
+      </a:dk2>
+      <a:lt2>
+        <a:srgbClr val="E7E6E6"/>
+      </a:lt2>
+      <a:accent1>
+        <a:srgbClr val="5B9BD5"/>
+      </a:accent1>
+      <a:accent2>
+        <a:srgbClr val="ED7D31"/>
+      </a:accent2>
+      <a:accent3>
+        <a:srgbClr val="A5A5A5"/>
+      </a:accent3>
+      <a:accent4>
+        <a:srgbClr val="FFC000"/>
+      </a:accent4>
+      <a:accent5>
+        <a:srgbClr val="4472C4"/>
+      </a:accent5>
+      <a:accent6>
+        <a:srgbClr val="70AD47"/>
+      </a:accent6>
+      <a:hlink>
+        <a:srgbClr val="0563C1"/>
+      </a:hlink>
+      <a:folHlink>
+        <a:srgbClr val="954F72"/>
+      </a:folHlink>
+    </a:clrScheme>
+    <a:fontScheme name="Office">
+      <a:majorFont>
+        <a:latin typeface="Calibri Light" panose="020F0302020204030204"/>
+        <a:ea typeface=""/>
+        <a:cs typeface=""/>
+        <a:font script="Jpan" typeface="ＭＳ Ｐゴシック"/>
+        <a:font script="Hang" typeface="맑은 고딕"/>
+        <a:font script="Hans" typeface="宋体"/>
+        <a:font script="Hant" typeface="新細明體"/>
+        <a:font script="Arab" typeface="Times New Roman"/>
+        <a:font script="Hebr" typeface="Times New Roman"/>
+        <a:font script="Thai" typeface="Angsana New"/>
+        <a:font script="Ethi" typeface="Nyala"/>
+        <a:font script="Beng" typeface="Vrinda"/>
+        <a:font script="Gujr" typeface="Shruti"/>
+        <a:font script="Khmr" typeface="MoolBoran"/>
+        <a:font script="Knda" typeface="Tunga"/>
+        <a:font script="Guru" typeface="Raavi"/>
+        <a:font script="Cans" typeface="Euphemia"/>
+        <a:font script="Cher" typeface="Plantagenet Cherokee"/>
+        <a:font script="Yiii" typeface="Microsoft Yi Baiti"/>
+        <a:font script="Tibt" typeface="Microsoft Himalaya"/>
+        <a:font script="Thaa" typeface="MV Boli"/>
+        <a:font script="Deva" typeface="Mangal"/>
+        <a:font script="Telu" typeface="Gautami"/>
+        <a:font script="Taml" typeface="Latha"/>
+        <a:font script="Syrc" typeface="Estrangelo Edessa"/>
+        <a:font script="Orya" typeface="Kalinga"/>
+        <a:font script="Mlym" typeface="Kartika"/>
+        <a:font script="Laoo" typeface="DokChampa"/>
+        <a:font script="Sinh" typeface="Iskoola Pota"/>
+        <a:font script="Mong" typeface="Mongolian Baiti"/>
+        <a:font script="Viet" typeface="Times New Roman"/>
+        <a:font script="Uigh" typeface="Microsoft Uighur"/>
+        <a:font script="Geor" typeface="Sylfaen"/>
+      </a:majorFont>
+      <a:minorFont>
+        <a:latin typeface="Calibri" panose="020F0502020204030204"/>
+        <a:ea typeface=""/>
+        <a:cs typeface=""/>
+        <a:font script="Jpan" typeface="ＭＳ Ｐゴシック"/>
+        <a:font script="Hang" typeface="맑은 고딕"/>
+        <a:font script="Hans" typeface="宋体"/>
+        <a:font script="Hant" typeface="新細明體"/>
+        <a:font script="Arab" typeface="Arial"/>
+        <a:font script="Hebr" typeface="Arial"/>
+        <a:font script="Thai" typeface="Cordia New"/>
+        <a:font script="Ethi" typeface="Nyala"/>
+        <a:font script="Beng" typeface="Vrinda"/>
+        <a:font script="Gujr" typeface="Shruti"/>
+        <a:font script="Khmr" typeface="DaunPenh"/>
+        <a:font script="Knda" typeface="Tunga"/>
+        <a:font script="Guru" typeface="Raavi"/>
+        <a:font script="Cans" typeface="Euphemia"/>
+        <a:font script="Cher" typeface="Plantagenet Cherokee"/>
+        <a:font script="Yiii" typeface="Microsoft Yi Baiti"/>
+        <a:font script="Tibt" typeface="Microsoft Himalaya"/>
+        <a:font script="Thaa" typeface="MV Boli"/>
+        <a:font script="Deva" typeface="Mangal"/>
+        <a:font script="Telu" typeface="Gautami"/>
+        <a:font script="Taml" typeface="Latha"/>
+        <a:font script="Syrc" typeface="Estrangelo Edessa"/>
+        <a:font script="Orya" typeface="Kalinga"/>
+        <a:font script="Mlym" typeface="Kartika"/>
+        <a:font script="Laoo" typeface="DokChampa"/>
+        <a:font script="Sinh" typeface="Iskoola Pota"/>
+        <a:font script="Mong" typeface="Mongolian Baiti"/>
+        <a:font script="Viet" typeface="Arial"/>
+        <a:font script="Uigh" typeface="Microsoft Uighur"/>
+        <a:font script="Geor" typeface="Sylfaen"/>
+      </a:minorFont>
+    </a:fontScheme>
+    <a:fmtScheme name="Office">
+      <a:fillStyleLst>
+        <a:solidFill>
+          <a:schemeClr val="phClr"/>
+        </a:solidFill>
+        <a:gradFill rotWithShape="1">
+          <a:gsLst>
+            <a:gs pos="0">
+              <a:schemeClr val="phClr">
+                <a:lumMod val="110000"/>
+                <a:satMod val="105000"/>
+                <a:tint val="67000"/>
+              </a:schemeClr>
+            </a:gs>
+            <a:gs pos="50000">
+              <a:schemeClr val="phClr">
+                <a:lumMod val="105000"/>
+                <a:satMod val="103000"/>
+                <a:tint val="73000"/>
+              </a:schemeClr>
+            </a:gs>
+            <a:gs pos="100000">
+              <a:schemeClr val="phClr">
+                <a:lumMod val="105000"/>
+                <a:satMod val="109000"/>
+                <a:tint val="81000"/>
+              </a:schemeClr>
+            </a:gs>
+          </a:gsLst>
+          <a:lin ang="5400000" scaled="0"/>
+        </a:gradFill>
+        <a:gradFill rotWithShape="1">
+          <a:gsLst>
+            <a:gs pos="0">
+              <a:schemeClr val="phClr">
+                <a:satMod val="103000"/>
+                <a:lumMod val="102000"/>
+                <a:tint val="94000"/>
+              </a:schemeClr>
+            </a:gs>
+            <a:gs pos="50000">
+              <a:schemeClr val="phClr">
+                <a:satMod val="110000"/>
+                <a:lumMod val="100000"/>
+                <a:shade val="100000"/>
+              </a:schemeClr>
+            </a:gs>
+            <a:gs pos="100000">
+              <a:schemeClr val="phClr">
+                <a:lumMod val="99000"/>
+                <a:satMod val="120000"/>
+                <a:shade val="78000"/>
+              </a:schemeClr>
+            </a:gs>
+          </a:gsLst>
+          <a:lin ang="5400000" scaled="0"/>
+        </a:gradFill>
+      </a:fillStyleLst>
+      <a:lnStyleLst>
+        <a:ln w="6350" cap="flat" cmpd="sng" algn="ctr">
+          <a:solidFill>
+            <a:schemeClr val="phClr"/>
+          </a:solidFill>
+          <a:prstDash val="solid"/>
+          <a:miter lim="800000"/>
+        </a:ln>
+        <a:ln w="12700" cap="flat" cmpd="sng" algn="ctr">
+          <a:solidFill>
+            <a:schemeClr val="phClr"/>
+          </a:solidFill>
+          <a:prstDash val="solid"/>
+          <a:miter lim="800000"/>
+        </a:ln>
+        <a:ln w="19050" cap="flat" cmpd="sng" algn="ctr">
+          <a:solidFill>
+            <a:schemeClr val="phClr"/>
+          </a:solidFill>
+          <a:prstDash val="solid"/>
+          <a:miter lim="800000"/>
+        </a:ln>
+      </a:lnStyleLst>
+      <a:effectStyleLst>
+        <a:effectStyle>
+          <a:effectLst/>
+        </a:effectStyle>
+        <a:effectStyle>
+          <a:effectLst/>
+        </a:effectStyle>
+        <a:effectStyle>
+          <a:effectLst>
+            <a:outerShdw blurRad="57150" dist="19050" dir="5400000" algn="ctr" rotWithShape="0">
+              <a:srgbClr val="000000">
+                <a:alpha val="63000"/>
+              </a:srgbClr>
+            </a:outerShdw>
+          </a:effectLst>
+        </a:effectStyle>
+      </a:effectStyleLst>
+      <a:bgFillStyleLst>
+        <a:solidFill>
+          <a:schemeClr val="phClr"/>
+        </a:solidFill>
+        <a:solidFill>
+          <a:schemeClr val="phClr">
+            <a:tint val="95000"/>
+            <a:satMod val="170000"/>
+          </a:schemeClr>
+        </a:solidFill>
+        <a:gradFill rotWithShape="1">
+          <a:gsLst>
+            <a:gs pos="0">
+              <a:schemeClr val="phClr">
+                <a:tint val="93000"/>
+                <a:satMod val="150000"/>
+                <a:shade val="98000"/>
+                <a:lumMod val="102000"/>
+              </a:schemeClr>
+            </a:gs>
+            <a:gs pos="50000">
+              <a:schemeClr val="phClr">
+                <a:tint val="98000"/>
+                <a:satMod val="130000"/>
+                <a:shade val="90000"/>
+                <a:lumMod val="103000"/>
+              </a:schemeClr>
+            </a:gs>
+            <a:gs pos="100000">
+              <a:schemeClr val="phClr">
+                <a:shade val="63000"/>
+                <a:satMod val="120000"/>
+              </a:schemeClr>
+            </a:gs>
+          </a:gsLst>
+          <a:lin ang="5400000" scaled="0"/>
+        </a:gradFill>
+      </a:bgFillStyleLst>
+    </a:fmtScheme>
+  </a:themeElements>
+  <a:objectDefaults/>
+  <a:extraClrSchemeLst/>
+  <a:extLst>
+    <a:ext uri="{05A4C25C-085E-4340-85A3-A5531E510DB2}">
+      <thm15:themeFamily xmlns:thm15="http://schemas.microsoft.com/office/thememl/2012/main" name="Office Theme" id="{62F939B6-93AF-4DB8-9C6B-D6C7DFDC589F}" vid="{4A3C46E8-61CC-4603-A589-7422A47A8E4A}"/>
+    </a:ext>
+  </a:extLst>
+</a:theme>
 </file>
</xml_diff>